<commit_message>
Profile Update- User Profile update (part - 4)
</commit_message>
<xml_diff>
--- a/.lessons/53 Profile Update/4 Profile Update- User Profile update (part - 4)/1.pptx
+++ b/.lessons/53 Profile Update/4 Profile Update- User Profile update (part - 4)/1.pptx
@@ -10,6 +10,10 @@
     <p:sldId id="416" r:id="rId4"/>
     <p:sldId id="414" r:id="rId5"/>
     <p:sldId id="400" r:id="rId6"/>
+    <p:sldId id="418" r:id="rId7"/>
+    <p:sldId id="417" r:id="rId8"/>
+    <p:sldId id="419" r:id="rId9"/>
+    <p:sldId id="420" r:id="rId10"/>
   </p:sldIdLst>
   <p:sldSz cx="12192000" cy="6858000"/>
   <p:notesSz cx="6858000" cy="9144000"/>
@@ -3350,8 +3354,8 @@
         </p:nvSpPr>
         <p:spPr>
           <a:xfrm>
-            <a:off x="217714" y="255046"/>
-            <a:ext cx="11756571" cy="355354"/>
+            <a:off x="217715" y="255046"/>
+            <a:ext cx="11893420" cy="1131848"/>
           </a:xfrm>
           <a:prstGeom prst="rect">
             <a:avLst/>
@@ -3371,21 +3375,72 @@
               <a:buNone/>
             </a:pPr>
             <a:r>
-              <a:rPr kumimoji="0" lang="en-US" altLang="en-US" sz="1300" b="0" i="0" u="none" strike="noStrike" cap="none" normalizeH="0" baseline="0">
-                <a:ln>
-                  <a:noFill/>
-                </a:ln>
-                <a:solidFill>
-                  <a:schemeClr val="tx1"/>
-                </a:solidFill>
-                <a:effectLst/>
+              <a:rPr lang="az-Latn-AZ" altLang="en-US" sz="2400">
                 <a:latin typeface="Arial" panose="020B0604020202020204" pitchFamily="34" charset="0"/>
               </a:rPr>
-              <a:t>.</a:t>
-            </a:r>
-          </a:p>
-        </p:txBody>
-      </p:sp>
+              <a:t>İndi isə, `</a:t>
+            </a:r>
+            <a:r>
+              <a:rPr lang="en-US" altLang="en-US" sz="2000" b="1">
+                <a:latin typeface="Arial" panose="020B0604020202020204" pitchFamily="34" charset="0"/>
+              </a:rPr>
+              <a:t>resources\views\frontend\dashboard\</a:t>
+            </a:r>
+            <a:r>
+              <a:rPr lang="en-US" altLang="en-US" sz="2000" b="1" u="sng">
+                <a:latin typeface="Arial" panose="020B0604020202020204" pitchFamily="34" charset="0"/>
+              </a:rPr>
+              <a:t>profile.blade.php</a:t>
+            </a:r>
+            <a:r>
+              <a:rPr lang="az-Latn-AZ" altLang="en-US" sz="2400">
+                <a:latin typeface="Arial" panose="020B0604020202020204" pitchFamily="34" charset="0"/>
+              </a:rPr>
+              <a:t>` faylındakı, şifrə yeniləmək üçün istifadə edilən elementləri konfiqurasiya edirik.</a:t>
+            </a:r>
+            <a:endParaRPr kumimoji="0" lang="en-US" altLang="en-US" sz="2400" b="0" i="0" u="none" strike="noStrike" cap="none" normalizeH="0" baseline="0">
+              <a:ln>
+                <a:noFill/>
+              </a:ln>
+              <a:solidFill>
+                <a:schemeClr val="tx1"/>
+              </a:solidFill>
+              <a:effectLst/>
+              <a:latin typeface="Arial" panose="020B0604020202020204" pitchFamily="34" charset="0"/>
+            </a:endParaRPr>
+          </a:p>
+        </p:txBody>
+      </p:sp>
+      <p:pic>
+        <p:nvPicPr>
+          <p:cNvPr id="4" name="Picture 3">
+            <a:extLst>
+              <a:ext uri="{FF2B5EF4-FFF2-40B4-BE49-F238E27FC236}">
+                <a16:creationId xmlns:a16="http://schemas.microsoft.com/office/drawing/2014/main" id="{E5C9F92C-631F-68C3-6DC6-256ADE1A00AA}"/>
+              </a:ext>
+            </a:extLst>
+          </p:cNvPr>
+          <p:cNvPicPr>
+            <a:picLocks noChangeAspect="1"/>
+          </p:cNvPicPr>
+          <p:nvPr/>
+        </p:nvPicPr>
+        <p:blipFill>
+          <a:blip r:embed="rId2"/>
+          <a:stretch>
+            <a:fillRect/>
+          </a:stretch>
+        </p:blipFill>
+        <p:spPr>
+          <a:xfrm>
+            <a:off x="5980922" y="1667048"/>
+            <a:ext cx="6211078" cy="5190952"/>
+          </a:xfrm>
+          <a:prstGeom prst="rect">
+            <a:avLst/>
+          </a:prstGeom>
+        </p:spPr>
+      </p:pic>
     </p:spTree>
     <p:extLst>
       <p:ext uri="{BB962C8B-B14F-4D97-AF65-F5344CB8AC3E}">
@@ -3437,7 +3492,7 @@
         <p:spPr>
           <a:xfrm>
             <a:off x="217714" y="255046"/>
-            <a:ext cx="11756571" cy="355354"/>
+            <a:ext cx="11756571" cy="2155847"/>
           </a:xfrm>
           <a:prstGeom prst="rect">
             <a:avLst/>
@@ -3457,7 +3512,7 @@
               <a:buNone/>
             </a:pPr>
             <a:r>
-              <a:rPr kumimoji="0" lang="en-US" altLang="en-US" sz="1300" b="0" i="0" u="none" strike="noStrike" cap="none" normalizeH="0" baseline="0">
+              <a:rPr kumimoji="0" lang="az-Latn-AZ" altLang="en-US" sz="1300" b="1" i="0" u="none" strike="noStrike" cap="none" normalizeH="0" baseline="0">
                 <a:ln>
                   <a:noFill/>
                 </a:ln>
@@ -3467,11 +3522,186 @@
                 <a:effectLst/>
                 <a:latin typeface="Arial" panose="020B0604020202020204" pitchFamily="34" charset="0"/>
               </a:rPr>
-              <a:t>.</a:t>
-            </a:r>
-          </a:p>
-        </p:txBody>
-      </p:sp>
+              <a:t>ROUTE</a:t>
+            </a:r>
+            <a:r>
+              <a:rPr kumimoji="0" lang="az-Latn-AZ" altLang="en-US" sz="1300" b="0" i="0" u="none" strike="noStrike" cap="none" normalizeH="0" baseline="0">
+                <a:ln>
+                  <a:noFill/>
+                </a:ln>
+                <a:solidFill>
+                  <a:schemeClr val="tx1"/>
+                </a:solidFill>
+                <a:effectLst/>
+                <a:latin typeface="Arial" panose="020B0604020202020204" pitchFamily="34" charset="0"/>
+              </a:rPr>
+              <a:t> -umuzu yaradırıq. </a:t>
+            </a:r>
+          </a:p>
+          <a:p>
+            <a:pPr>
+              <a:lnSpc>
+                <a:spcPct val="150000"/>
+              </a:lnSpc>
+              <a:buNone/>
+            </a:pPr>
+            <a:endParaRPr lang="az-Latn-AZ" altLang="en-US" sz="1300">
+              <a:latin typeface="Arial" panose="020B0604020202020204" pitchFamily="34" charset="0"/>
+            </a:endParaRPr>
+          </a:p>
+          <a:p>
+            <a:pPr>
+              <a:lnSpc>
+                <a:spcPct val="150000"/>
+              </a:lnSpc>
+              <a:buNone/>
+            </a:pPr>
+            <a:r>
+              <a:rPr lang="en-US" altLang="en-US" sz="1300" b="1">
+                <a:latin typeface="Arial" panose="020B0604020202020204" pitchFamily="34" charset="0"/>
+              </a:rPr>
+              <a:t>Qeyd</a:t>
+            </a:r>
+            <a:r>
+              <a:rPr lang="en-US" altLang="en-US" sz="1300">
+                <a:latin typeface="Arial" panose="020B0604020202020204" pitchFamily="34" charset="0"/>
+              </a:rPr>
+              <a:t>:</a:t>
+            </a:r>
+          </a:p>
+          <a:p>
+            <a:pPr marL="742950" lvl="1" indent="-285750">
+              <a:lnSpc>
+                <a:spcPct val="150000"/>
+              </a:lnSpc>
+              <a:buFont typeface="Wingdings" panose="05000000000000000000" pitchFamily="2" charset="2"/>
+              <a:buChar char="q"/>
+            </a:pPr>
+            <a:r>
+              <a:rPr lang="en-US" altLang="en-US" sz="1300" b="1">
+                <a:latin typeface="Arial" panose="020B0604020202020204" pitchFamily="34" charset="0"/>
+              </a:rPr>
+              <a:t>PUT</a:t>
+            </a:r>
+            <a:r>
+              <a:rPr lang="en-US" altLang="en-US" sz="1300">
+                <a:latin typeface="Arial" panose="020B0604020202020204" pitchFamily="34" charset="0"/>
+              </a:rPr>
+              <a:t> metodu profile üçün updateProfile() metodunu çağırır.</a:t>
+            </a:r>
+          </a:p>
+          <a:p>
+            <a:pPr marL="742950" lvl="1" indent="-285750">
+              <a:lnSpc>
+                <a:spcPct val="150000"/>
+              </a:lnSpc>
+              <a:buFont typeface="Wingdings" panose="05000000000000000000" pitchFamily="2" charset="2"/>
+              <a:buChar char="q"/>
+            </a:pPr>
+            <a:r>
+              <a:rPr lang="en-US" altLang="en-US" sz="1300" b="1">
+                <a:latin typeface="Arial" panose="020B0604020202020204" pitchFamily="34" charset="0"/>
+              </a:rPr>
+              <a:t>POST</a:t>
+            </a:r>
+            <a:r>
+              <a:rPr lang="en-US" altLang="en-US" sz="1300">
+                <a:latin typeface="Arial" panose="020B0604020202020204" pitchFamily="34" charset="0"/>
+              </a:rPr>
+              <a:t> metodu profile üçün updatePassword() metodunu çağırır.</a:t>
+            </a:r>
+          </a:p>
+          <a:p>
+            <a:pPr>
+              <a:lnSpc>
+                <a:spcPct val="150000"/>
+              </a:lnSpc>
+              <a:buNone/>
+            </a:pPr>
+            <a:endParaRPr lang="en-US" altLang="en-US" sz="1300">
+              <a:latin typeface="Arial" panose="020B0604020202020204" pitchFamily="34" charset="0"/>
+            </a:endParaRPr>
+          </a:p>
+          <a:p>
+            <a:pPr>
+              <a:lnSpc>
+                <a:spcPct val="150000"/>
+              </a:lnSpc>
+              <a:buNone/>
+            </a:pPr>
+            <a:r>
+              <a:rPr lang="en-US" altLang="en-US" sz="1300">
+                <a:latin typeface="Arial" panose="020B0604020202020204" pitchFamily="34" charset="0"/>
+              </a:rPr>
+              <a:t>Hər iki route eyni URL-yə (</a:t>
+            </a:r>
+            <a:r>
+              <a:rPr lang="en-US" altLang="en-US" sz="1300" b="1">
+                <a:latin typeface="Arial" panose="020B0604020202020204" pitchFamily="34" charset="0"/>
+              </a:rPr>
+              <a:t>user/profile</a:t>
+            </a:r>
+            <a:r>
+              <a:rPr lang="en-US" altLang="en-US" sz="1300">
+                <a:latin typeface="Arial" panose="020B0604020202020204" pitchFamily="34" charset="0"/>
+              </a:rPr>
+              <a:t>) yönəldiyi üçün, HTTP methodlarına görə </a:t>
+            </a:r>
+            <a:r>
+              <a:rPr lang="en-US" altLang="en-US" sz="1300" b="1">
+                <a:latin typeface="Arial" panose="020B0604020202020204" pitchFamily="34" charset="0"/>
+              </a:rPr>
+              <a:t>fərqli funksiyalar </a:t>
+            </a:r>
+            <a:r>
+              <a:rPr lang="en-US" altLang="en-US" sz="1300">
+                <a:latin typeface="Arial" panose="020B0604020202020204" pitchFamily="34" charset="0"/>
+              </a:rPr>
+              <a:t>çağırılır.</a:t>
+            </a:r>
+            <a:endParaRPr kumimoji="0" lang="en-US" altLang="en-US" sz="1300" b="0" i="0" u="none" strike="noStrike" cap="none" normalizeH="0" baseline="0">
+              <a:ln>
+                <a:noFill/>
+              </a:ln>
+              <a:solidFill>
+                <a:schemeClr val="tx1"/>
+              </a:solidFill>
+              <a:effectLst/>
+              <a:latin typeface="Arial" panose="020B0604020202020204" pitchFamily="34" charset="0"/>
+            </a:endParaRPr>
+          </a:p>
+        </p:txBody>
+      </p:sp>
+      <p:pic>
+        <p:nvPicPr>
+          <p:cNvPr id="4" name="Picture 3">
+            <a:extLst>
+              <a:ext uri="{FF2B5EF4-FFF2-40B4-BE49-F238E27FC236}">
+                <a16:creationId xmlns:a16="http://schemas.microsoft.com/office/drawing/2014/main" id="{5B8788C6-AA34-3B8C-97CA-2241DBE79440}"/>
+              </a:ext>
+            </a:extLst>
+          </p:cNvPr>
+          <p:cNvPicPr>
+            <a:picLocks noChangeAspect="1"/>
+          </p:cNvPicPr>
+          <p:nvPr/>
+        </p:nvPicPr>
+        <p:blipFill>
+          <a:blip r:embed="rId2"/>
+          <a:stretch>
+            <a:fillRect/>
+          </a:stretch>
+        </p:blipFill>
+        <p:spPr>
+          <a:xfrm>
+            <a:off x="0" y="4695523"/>
+            <a:ext cx="9507277" cy="2162477"/>
+          </a:xfrm>
+          <a:prstGeom prst="rect">
+            <a:avLst/>
+          </a:prstGeom>
+        </p:spPr>
+      </p:pic>
     </p:spTree>
     <p:extLst>
       <p:ext uri="{BB962C8B-B14F-4D97-AF65-F5344CB8AC3E}">
@@ -3543,21 +3773,857 @@
               <a:buNone/>
             </a:pPr>
             <a:r>
-              <a:rPr kumimoji="0" lang="en-US" altLang="en-US" sz="1300" b="0" i="0" u="none" strike="noStrike" cap="none" normalizeH="0" baseline="0">
-                <a:ln>
-                  <a:noFill/>
-                </a:ln>
-                <a:solidFill>
-                  <a:schemeClr val="tx1"/>
-                </a:solidFill>
-                <a:effectLst/>
+              <a:rPr lang="en-US" altLang="en-US" sz="1300" b="1">
                 <a:latin typeface="Arial" panose="020B0604020202020204" pitchFamily="34" charset="0"/>
               </a:rPr>
-              <a:t>.</a:t>
-            </a:r>
-          </a:p>
-        </p:txBody>
-      </p:sp>
+              <a:t>POST</a:t>
+            </a:r>
+            <a:r>
+              <a:rPr lang="en-US" altLang="en-US" sz="1300">
+                <a:latin typeface="Arial" panose="020B0604020202020204" pitchFamily="34" charset="0"/>
+              </a:rPr>
+              <a:t>, </a:t>
+            </a:r>
+            <a:r>
+              <a:rPr lang="en-US" altLang="en-US" sz="1300" b="1">
+                <a:latin typeface="Arial" panose="020B0604020202020204" pitchFamily="34" charset="0"/>
+              </a:rPr>
+              <a:t>PUT</a:t>
+            </a:r>
+            <a:r>
+              <a:rPr lang="en-US" altLang="en-US" sz="1300">
+                <a:latin typeface="Arial" panose="020B0604020202020204" pitchFamily="34" charset="0"/>
+              </a:rPr>
+              <a:t> və </a:t>
+            </a:r>
+            <a:r>
+              <a:rPr lang="en-US" altLang="en-US" sz="1300" b="1">
+                <a:latin typeface="Arial" panose="020B0604020202020204" pitchFamily="34" charset="0"/>
+              </a:rPr>
+              <a:t>PATCH</a:t>
+            </a:r>
+            <a:r>
+              <a:rPr lang="en-US" altLang="en-US" sz="1300">
+                <a:latin typeface="Arial" panose="020B0604020202020204" pitchFamily="34" charset="0"/>
+              </a:rPr>
+              <a:t> metodlarının fərqləri nədir?</a:t>
+            </a:r>
+            <a:endParaRPr kumimoji="0" lang="en-US" altLang="en-US" sz="1300" b="0" i="0" u="none" strike="noStrike" cap="none" normalizeH="0" baseline="0">
+              <a:ln>
+                <a:noFill/>
+              </a:ln>
+              <a:solidFill>
+                <a:schemeClr val="tx1"/>
+              </a:solidFill>
+              <a:effectLst/>
+              <a:latin typeface="Arial" panose="020B0604020202020204" pitchFamily="34" charset="0"/>
+            </a:endParaRPr>
+          </a:p>
+        </p:txBody>
+      </p:sp>
+      <p:graphicFrame>
+        <p:nvGraphicFramePr>
+          <p:cNvPr id="2" name="Table 1">
+            <a:extLst>
+              <a:ext uri="{FF2B5EF4-FFF2-40B4-BE49-F238E27FC236}">
+                <a16:creationId xmlns:a16="http://schemas.microsoft.com/office/drawing/2014/main" id="{62B9A3B0-8FA9-BA3F-84FF-D2F4180DB0A1}"/>
+              </a:ext>
+            </a:extLst>
+          </p:cNvPr>
+          <p:cNvGraphicFramePr>
+            <a:graphicFrameLocks noGrp="1"/>
+          </p:cNvGraphicFramePr>
+          <p:nvPr>
+            <p:extLst>
+              <p:ext uri="{D42A27DB-BD31-4B8C-83A1-F6EECF244321}">
+                <p14:modId xmlns:p14="http://schemas.microsoft.com/office/powerpoint/2010/main" val="3897545410"/>
+              </p:ext>
+            </p:extLst>
+          </p:nvPr>
+        </p:nvGraphicFramePr>
+        <p:xfrm>
+          <a:off x="217714" y="997769"/>
+          <a:ext cx="11822990" cy="4050091"/>
+        </p:xfrm>
+        <a:graphic>
+          <a:graphicData uri="http://schemas.openxmlformats.org/drawingml/2006/table">
+            <a:tbl>
+              <a:tblPr/>
+              <a:tblGrid>
+                <a:gridCol w="1416939">
+                  <a:extLst>
+                    <a:ext uri="{9D8B030D-6E8A-4147-A177-3AD203B41FA5}">
+                      <a16:colId xmlns:a16="http://schemas.microsoft.com/office/drawing/2014/main" val="1796316123"/>
+                    </a:ext>
+                  </a:extLst>
+                </a:gridCol>
+                <a:gridCol w="3907731">
+                  <a:extLst>
+                    <a:ext uri="{9D8B030D-6E8A-4147-A177-3AD203B41FA5}">
+                      <a16:colId xmlns:a16="http://schemas.microsoft.com/office/drawing/2014/main" val="2597035172"/>
+                    </a:ext>
+                  </a:extLst>
+                </a:gridCol>
+                <a:gridCol w="6498320">
+                  <a:extLst>
+                    <a:ext uri="{9D8B030D-6E8A-4147-A177-3AD203B41FA5}">
+                      <a16:colId xmlns:a16="http://schemas.microsoft.com/office/drawing/2014/main" val="2532067129"/>
+                    </a:ext>
+                  </a:extLst>
+                </a:gridCol>
+              </a:tblGrid>
+              <a:tr h="578584">
+                <a:tc>
+                  <a:txBody>
+                    <a:bodyPr/>
+                    <a:lstStyle/>
+                    <a:p>
+                      <a:r>
+                        <a:rPr lang="en-US" b="1"/>
+                        <a:t>HTTP Metod</a:t>
+                      </a:r>
+                    </a:p>
+                  </a:txBody>
+                  <a:tcPr anchor="ctr">
+                    <a:lnL w="12700" cap="flat" cmpd="sng" algn="ctr">
+                      <a:solidFill>
+                        <a:schemeClr val="tx1"/>
+                      </a:solidFill>
+                      <a:prstDash val="solid"/>
+                      <a:round/>
+                      <a:headEnd type="none" w="med" len="med"/>
+                      <a:tailEnd type="none" w="med" len="med"/>
+                    </a:lnL>
+                    <a:lnR w="12700" cap="flat" cmpd="sng" algn="ctr">
+                      <a:solidFill>
+                        <a:schemeClr val="tx1"/>
+                      </a:solidFill>
+                      <a:prstDash val="solid"/>
+                      <a:round/>
+                      <a:headEnd type="none" w="med" len="med"/>
+                      <a:tailEnd type="none" w="med" len="med"/>
+                    </a:lnR>
+                    <a:lnT w="12700" cap="flat" cmpd="sng" algn="ctr">
+                      <a:solidFill>
+                        <a:schemeClr val="tx1"/>
+                      </a:solidFill>
+                      <a:prstDash val="solid"/>
+                      <a:round/>
+                      <a:headEnd type="none" w="med" len="med"/>
+                      <a:tailEnd type="none" w="med" len="med"/>
+                    </a:lnT>
+                    <a:lnB w="12700" cap="flat" cmpd="sng" algn="ctr">
+                      <a:solidFill>
+                        <a:schemeClr val="tx1"/>
+                      </a:solidFill>
+                      <a:prstDash val="solid"/>
+                      <a:round/>
+                      <a:headEnd type="none" w="med" len="med"/>
+                      <a:tailEnd type="none" w="med" len="med"/>
+                    </a:lnB>
+                    <a:lnTlToBr w="12700" cmpd="sng">
+                      <a:noFill/>
+                      <a:prstDash val="solid"/>
+                    </a:lnTlToBr>
+                    <a:lnBlToTr w="12700" cmpd="sng">
+                      <a:noFill/>
+                      <a:prstDash val="solid"/>
+                    </a:lnBlToTr>
+                    <a:solidFill>
+                      <a:schemeClr val="accent2"/>
+                    </a:solidFill>
+                  </a:tcPr>
+                </a:tc>
+                <a:tc>
+                  <a:txBody>
+                    <a:bodyPr/>
+                    <a:lstStyle/>
+                    <a:p>
+                      <a:r>
+                        <a:rPr lang="en-US" b="1"/>
+                        <a:t>Məqsəd</a:t>
+                      </a:r>
+                    </a:p>
+                  </a:txBody>
+                  <a:tcPr anchor="ctr">
+                    <a:lnL w="12700" cap="flat" cmpd="sng" algn="ctr">
+                      <a:solidFill>
+                        <a:schemeClr val="tx1"/>
+                      </a:solidFill>
+                      <a:prstDash val="solid"/>
+                      <a:round/>
+                      <a:headEnd type="none" w="med" len="med"/>
+                      <a:tailEnd type="none" w="med" len="med"/>
+                    </a:lnL>
+                    <a:lnR w="12700" cap="flat" cmpd="sng" algn="ctr">
+                      <a:solidFill>
+                        <a:schemeClr val="tx1"/>
+                      </a:solidFill>
+                      <a:prstDash val="solid"/>
+                      <a:round/>
+                      <a:headEnd type="none" w="med" len="med"/>
+                      <a:tailEnd type="none" w="med" len="med"/>
+                    </a:lnR>
+                    <a:lnT w="12700" cap="flat" cmpd="sng" algn="ctr">
+                      <a:solidFill>
+                        <a:schemeClr val="tx1"/>
+                      </a:solidFill>
+                      <a:prstDash val="solid"/>
+                      <a:round/>
+                      <a:headEnd type="none" w="med" len="med"/>
+                      <a:tailEnd type="none" w="med" len="med"/>
+                    </a:lnT>
+                    <a:lnB w="12700" cap="flat" cmpd="sng" algn="ctr">
+                      <a:solidFill>
+                        <a:schemeClr val="tx1"/>
+                      </a:solidFill>
+                      <a:prstDash val="solid"/>
+                      <a:round/>
+                      <a:headEnd type="none" w="med" len="med"/>
+                      <a:tailEnd type="none" w="med" len="med"/>
+                    </a:lnB>
+                    <a:lnTlToBr w="12700" cmpd="sng">
+                      <a:noFill/>
+                      <a:prstDash val="solid"/>
+                    </a:lnTlToBr>
+                    <a:lnBlToTr w="12700" cmpd="sng">
+                      <a:noFill/>
+                      <a:prstDash val="solid"/>
+                    </a:lnBlToTr>
+                    <a:solidFill>
+                      <a:schemeClr val="accent2"/>
+                    </a:solidFill>
+                  </a:tcPr>
+                </a:tc>
+                <a:tc>
+                  <a:txBody>
+                    <a:bodyPr/>
+                    <a:lstStyle/>
+                    <a:p>
+                      <a:r>
+                        <a:rPr lang="en-US" b="1"/>
+                        <a:t>Təsvir</a:t>
+                      </a:r>
+                    </a:p>
+                  </a:txBody>
+                  <a:tcPr anchor="ctr">
+                    <a:lnL w="12700" cap="flat" cmpd="sng" algn="ctr">
+                      <a:solidFill>
+                        <a:schemeClr val="tx1"/>
+                      </a:solidFill>
+                      <a:prstDash val="solid"/>
+                      <a:round/>
+                      <a:headEnd type="none" w="med" len="med"/>
+                      <a:tailEnd type="none" w="med" len="med"/>
+                    </a:lnL>
+                    <a:lnR w="12700" cap="flat" cmpd="sng" algn="ctr">
+                      <a:solidFill>
+                        <a:schemeClr val="tx1"/>
+                      </a:solidFill>
+                      <a:prstDash val="solid"/>
+                      <a:round/>
+                      <a:headEnd type="none" w="med" len="med"/>
+                      <a:tailEnd type="none" w="med" len="med"/>
+                    </a:lnR>
+                    <a:lnT w="12700" cap="flat" cmpd="sng" algn="ctr">
+                      <a:solidFill>
+                        <a:schemeClr val="tx1"/>
+                      </a:solidFill>
+                      <a:prstDash val="solid"/>
+                      <a:round/>
+                      <a:headEnd type="none" w="med" len="med"/>
+                      <a:tailEnd type="none" w="med" len="med"/>
+                    </a:lnT>
+                    <a:lnB w="12700" cap="flat" cmpd="sng" algn="ctr">
+                      <a:solidFill>
+                        <a:schemeClr val="tx1"/>
+                      </a:solidFill>
+                      <a:prstDash val="solid"/>
+                      <a:round/>
+                      <a:headEnd type="none" w="med" len="med"/>
+                      <a:tailEnd type="none" w="med" len="med"/>
+                    </a:lnB>
+                    <a:lnTlToBr w="12700" cmpd="sng">
+                      <a:noFill/>
+                      <a:prstDash val="solid"/>
+                    </a:lnTlToBr>
+                    <a:lnBlToTr w="12700" cmpd="sng">
+                      <a:noFill/>
+                      <a:prstDash val="solid"/>
+                    </a:lnBlToTr>
+                    <a:solidFill>
+                      <a:schemeClr val="accent2"/>
+                    </a:solidFill>
+                  </a:tcPr>
+                </a:tc>
+                <a:extLst>
+                  <a:ext uri="{0D108BD9-81ED-4DB2-BD59-A6C34878D82A}">
+                    <a16:rowId xmlns:a16="http://schemas.microsoft.com/office/drawing/2014/main" val="1630306091"/>
+                  </a:ext>
+                </a:extLst>
+              </a:tr>
+              <a:tr h="1446461">
+                <a:tc>
+                  <a:txBody>
+                    <a:bodyPr/>
+                    <a:lstStyle/>
+                    <a:p>
+                      <a:r>
+                        <a:rPr lang="en-US" b="1"/>
+                        <a:t>POST</a:t>
+                      </a:r>
+                    </a:p>
+                  </a:txBody>
+                  <a:tcPr anchor="ctr">
+                    <a:lnL w="12700" cap="flat" cmpd="sng" algn="ctr">
+                      <a:solidFill>
+                        <a:schemeClr val="tx1"/>
+                      </a:solidFill>
+                      <a:prstDash val="solid"/>
+                      <a:round/>
+                      <a:headEnd type="none" w="med" len="med"/>
+                      <a:tailEnd type="none" w="med" len="med"/>
+                    </a:lnL>
+                    <a:lnR w="12700" cap="flat" cmpd="sng" algn="ctr">
+                      <a:solidFill>
+                        <a:schemeClr val="tx1"/>
+                      </a:solidFill>
+                      <a:prstDash val="solid"/>
+                      <a:round/>
+                      <a:headEnd type="none" w="med" len="med"/>
+                      <a:tailEnd type="none" w="med" len="med"/>
+                    </a:lnR>
+                    <a:lnT w="12700" cap="flat" cmpd="sng" algn="ctr">
+                      <a:solidFill>
+                        <a:schemeClr val="tx1"/>
+                      </a:solidFill>
+                      <a:prstDash val="solid"/>
+                      <a:round/>
+                      <a:headEnd type="none" w="med" len="med"/>
+                      <a:tailEnd type="none" w="med" len="med"/>
+                    </a:lnT>
+                    <a:lnB w="12700" cap="flat" cmpd="sng" algn="ctr">
+                      <a:solidFill>
+                        <a:schemeClr val="tx1"/>
+                      </a:solidFill>
+                      <a:prstDash val="solid"/>
+                      <a:round/>
+                      <a:headEnd type="none" w="med" len="med"/>
+                      <a:tailEnd type="none" w="med" len="med"/>
+                    </a:lnB>
+                    <a:lnTlToBr w="12700" cmpd="sng">
+                      <a:noFill/>
+                      <a:prstDash val="solid"/>
+                    </a:lnTlToBr>
+                    <a:lnBlToTr w="12700" cmpd="sng">
+                      <a:noFill/>
+                      <a:prstDash val="solid"/>
+                    </a:lnBlToTr>
+                    <a:noFill/>
+                  </a:tcPr>
+                </a:tc>
+                <a:tc>
+                  <a:txBody>
+                    <a:bodyPr/>
+                    <a:lstStyle/>
+                    <a:p>
+                      <a:r>
+                        <a:rPr lang="en-US" b="1"/>
+                        <a:t>Yeni bir resurs yaratmaq</a:t>
+                      </a:r>
+                      <a:r>
+                        <a:rPr lang="en-US"/>
+                        <a:t> və ya qeyri-standart dəyişikliklər</a:t>
+                      </a:r>
+                    </a:p>
+                  </a:txBody>
+                  <a:tcPr anchor="ctr">
+                    <a:lnL w="12700" cap="flat" cmpd="sng" algn="ctr">
+                      <a:solidFill>
+                        <a:schemeClr val="tx1"/>
+                      </a:solidFill>
+                      <a:prstDash val="solid"/>
+                      <a:round/>
+                      <a:headEnd type="none" w="med" len="med"/>
+                      <a:tailEnd type="none" w="med" len="med"/>
+                    </a:lnL>
+                    <a:lnR w="12700" cap="flat" cmpd="sng" algn="ctr">
+                      <a:solidFill>
+                        <a:schemeClr val="tx1"/>
+                      </a:solidFill>
+                      <a:prstDash val="solid"/>
+                      <a:round/>
+                      <a:headEnd type="none" w="med" len="med"/>
+                      <a:tailEnd type="none" w="med" len="med"/>
+                    </a:lnR>
+                    <a:lnT w="12700" cap="flat" cmpd="sng" algn="ctr">
+                      <a:solidFill>
+                        <a:schemeClr val="tx1"/>
+                      </a:solidFill>
+                      <a:prstDash val="solid"/>
+                      <a:round/>
+                      <a:headEnd type="none" w="med" len="med"/>
+                      <a:tailEnd type="none" w="med" len="med"/>
+                    </a:lnT>
+                    <a:lnB w="12700" cap="flat" cmpd="sng" algn="ctr">
+                      <a:solidFill>
+                        <a:schemeClr val="tx1"/>
+                      </a:solidFill>
+                      <a:prstDash val="solid"/>
+                      <a:round/>
+                      <a:headEnd type="none" w="med" len="med"/>
+                      <a:tailEnd type="none" w="med" len="med"/>
+                    </a:lnB>
+                    <a:lnTlToBr w="12700" cmpd="sng">
+                      <a:noFill/>
+                      <a:prstDash val="solid"/>
+                    </a:lnTlToBr>
+                    <a:lnBlToTr w="12700" cmpd="sng">
+                      <a:noFill/>
+                      <a:prstDash val="solid"/>
+                    </a:lnBlToTr>
+                    <a:noFill/>
+                  </a:tcPr>
+                </a:tc>
+                <a:tc>
+                  <a:txBody>
+                    <a:bodyPr/>
+                    <a:lstStyle/>
+                    <a:p>
+                      <a:r>
+                        <a:rPr lang="en-US"/>
+                        <a:t>Dinamik fəaliyyətlər üçün istifadə olunur, məsələn: parol dəyişmək, form göndərmək, mesaj yazmaq</a:t>
+                      </a:r>
+                    </a:p>
+                  </a:txBody>
+                  <a:tcPr anchor="ctr">
+                    <a:lnL w="12700" cap="flat" cmpd="sng" algn="ctr">
+                      <a:solidFill>
+                        <a:schemeClr val="tx1"/>
+                      </a:solidFill>
+                      <a:prstDash val="solid"/>
+                      <a:round/>
+                      <a:headEnd type="none" w="med" len="med"/>
+                      <a:tailEnd type="none" w="med" len="med"/>
+                    </a:lnL>
+                    <a:lnR w="12700" cap="flat" cmpd="sng" algn="ctr">
+                      <a:solidFill>
+                        <a:schemeClr val="tx1"/>
+                      </a:solidFill>
+                      <a:prstDash val="solid"/>
+                      <a:round/>
+                      <a:headEnd type="none" w="med" len="med"/>
+                      <a:tailEnd type="none" w="med" len="med"/>
+                    </a:lnR>
+                    <a:lnT w="12700" cap="flat" cmpd="sng" algn="ctr">
+                      <a:solidFill>
+                        <a:schemeClr val="tx1"/>
+                      </a:solidFill>
+                      <a:prstDash val="solid"/>
+                      <a:round/>
+                      <a:headEnd type="none" w="med" len="med"/>
+                      <a:tailEnd type="none" w="med" len="med"/>
+                    </a:lnT>
+                    <a:lnB w="12700" cap="flat" cmpd="sng" algn="ctr">
+                      <a:solidFill>
+                        <a:schemeClr val="tx1"/>
+                      </a:solidFill>
+                      <a:prstDash val="solid"/>
+                      <a:round/>
+                      <a:headEnd type="none" w="med" len="med"/>
+                      <a:tailEnd type="none" w="med" len="med"/>
+                    </a:lnB>
+                    <a:lnTlToBr w="12700" cmpd="sng">
+                      <a:noFill/>
+                      <a:prstDash val="solid"/>
+                    </a:lnTlToBr>
+                    <a:lnBlToTr w="12700" cmpd="sng">
+                      <a:noFill/>
+                      <a:prstDash val="solid"/>
+                    </a:lnBlToTr>
+                    <a:noFill/>
+                  </a:tcPr>
+                </a:tc>
+                <a:extLst>
+                  <a:ext uri="{0D108BD9-81ED-4DB2-BD59-A6C34878D82A}">
+                    <a16:rowId xmlns:a16="http://schemas.microsoft.com/office/drawing/2014/main" val="3807429491"/>
+                  </a:ext>
+                </a:extLst>
+              </a:tr>
+              <a:tr h="1012523">
+                <a:tc>
+                  <a:txBody>
+                    <a:bodyPr/>
+                    <a:lstStyle/>
+                    <a:p>
+                      <a:r>
+                        <a:rPr lang="en-US" b="1"/>
+                        <a:t>PUT</a:t>
+                      </a:r>
+                    </a:p>
+                  </a:txBody>
+                  <a:tcPr anchor="ctr">
+                    <a:lnL w="12700" cap="flat" cmpd="sng" algn="ctr">
+                      <a:solidFill>
+                        <a:schemeClr val="tx1"/>
+                      </a:solidFill>
+                      <a:prstDash val="solid"/>
+                      <a:round/>
+                      <a:headEnd type="none" w="med" len="med"/>
+                      <a:tailEnd type="none" w="med" len="med"/>
+                    </a:lnL>
+                    <a:lnR w="12700" cap="flat" cmpd="sng" algn="ctr">
+                      <a:solidFill>
+                        <a:schemeClr val="tx1"/>
+                      </a:solidFill>
+                      <a:prstDash val="solid"/>
+                      <a:round/>
+                      <a:headEnd type="none" w="med" len="med"/>
+                      <a:tailEnd type="none" w="med" len="med"/>
+                    </a:lnR>
+                    <a:lnT w="12700" cap="flat" cmpd="sng" algn="ctr">
+                      <a:solidFill>
+                        <a:schemeClr val="tx1"/>
+                      </a:solidFill>
+                      <a:prstDash val="solid"/>
+                      <a:round/>
+                      <a:headEnd type="none" w="med" len="med"/>
+                      <a:tailEnd type="none" w="med" len="med"/>
+                    </a:lnT>
+                    <a:lnB w="12700" cap="flat" cmpd="sng" algn="ctr">
+                      <a:solidFill>
+                        <a:schemeClr val="tx1"/>
+                      </a:solidFill>
+                      <a:prstDash val="solid"/>
+                      <a:round/>
+                      <a:headEnd type="none" w="med" len="med"/>
+                      <a:tailEnd type="none" w="med" len="med"/>
+                    </a:lnB>
+                    <a:lnTlToBr w="12700" cmpd="sng">
+                      <a:noFill/>
+                      <a:prstDash val="solid"/>
+                    </a:lnTlToBr>
+                    <a:lnBlToTr w="12700" cmpd="sng">
+                      <a:noFill/>
+                      <a:prstDash val="solid"/>
+                    </a:lnBlToTr>
+                    <a:noFill/>
+                  </a:tcPr>
+                </a:tc>
+                <a:tc>
+                  <a:txBody>
+                    <a:bodyPr/>
+                    <a:lstStyle/>
+                    <a:p>
+                      <a:r>
+                        <a:rPr lang="en-US" b="1"/>
+                        <a:t>Var olan bir resursu tam olaraq dəyişdirmək</a:t>
+                      </a:r>
+                      <a:endParaRPr lang="en-US"/>
+                    </a:p>
+                  </a:txBody>
+                  <a:tcPr anchor="ctr">
+                    <a:lnL w="12700" cap="flat" cmpd="sng" algn="ctr">
+                      <a:solidFill>
+                        <a:schemeClr val="tx1"/>
+                      </a:solidFill>
+                      <a:prstDash val="solid"/>
+                      <a:round/>
+                      <a:headEnd type="none" w="med" len="med"/>
+                      <a:tailEnd type="none" w="med" len="med"/>
+                    </a:lnL>
+                    <a:lnR w="12700" cap="flat" cmpd="sng" algn="ctr">
+                      <a:solidFill>
+                        <a:schemeClr val="tx1"/>
+                      </a:solidFill>
+                      <a:prstDash val="solid"/>
+                      <a:round/>
+                      <a:headEnd type="none" w="med" len="med"/>
+                      <a:tailEnd type="none" w="med" len="med"/>
+                    </a:lnR>
+                    <a:lnT w="12700" cap="flat" cmpd="sng" algn="ctr">
+                      <a:solidFill>
+                        <a:schemeClr val="tx1"/>
+                      </a:solidFill>
+                      <a:prstDash val="solid"/>
+                      <a:round/>
+                      <a:headEnd type="none" w="med" len="med"/>
+                      <a:tailEnd type="none" w="med" len="med"/>
+                    </a:lnT>
+                    <a:lnB w="12700" cap="flat" cmpd="sng" algn="ctr">
+                      <a:solidFill>
+                        <a:schemeClr val="tx1"/>
+                      </a:solidFill>
+                      <a:prstDash val="solid"/>
+                      <a:round/>
+                      <a:headEnd type="none" w="med" len="med"/>
+                      <a:tailEnd type="none" w="med" len="med"/>
+                    </a:lnB>
+                    <a:lnTlToBr w="12700" cmpd="sng">
+                      <a:noFill/>
+                      <a:prstDash val="solid"/>
+                    </a:lnTlToBr>
+                    <a:lnBlToTr w="12700" cmpd="sng">
+                      <a:noFill/>
+                      <a:prstDash val="solid"/>
+                    </a:lnBlToTr>
+                    <a:noFill/>
+                  </a:tcPr>
+                </a:tc>
+                <a:tc>
+                  <a:txBody>
+                    <a:bodyPr/>
+                    <a:lstStyle/>
+                    <a:p>
+                      <a:r>
+                        <a:rPr lang="en-US"/>
+                        <a:t>Mövcud user modelini bütünlükdə güncəlləmək üçün uyğundur</a:t>
+                      </a:r>
+                    </a:p>
+                  </a:txBody>
+                  <a:tcPr anchor="ctr">
+                    <a:lnL w="12700" cap="flat" cmpd="sng" algn="ctr">
+                      <a:solidFill>
+                        <a:schemeClr val="tx1"/>
+                      </a:solidFill>
+                      <a:prstDash val="solid"/>
+                      <a:round/>
+                      <a:headEnd type="none" w="med" len="med"/>
+                      <a:tailEnd type="none" w="med" len="med"/>
+                    </a:lnL>
+                    <a:lnR w="12700" cap="flat" cmpd="sng" algn="ctr">
+                      <a:solidFill>
+                        <a:schemeClr val="tx1"/>
+                      </a:solidFill>
+                      <a:prstDash val="solid"/>
+                      <a:round/>
+                      <a:headEnd type="none" w="med" len="med"/>
+                      <a:tailEnd type="none" w="med" len="med"/>
+                    </a:lnR>
+                    <a:lnT w="12700" cap="flat" cmpd="sng" algn="ctr">
+                      <a:solidFill>
+                        <a:schemeClr val="tx1"/>
+                      </a:solidFill>
+                      <a:prstDash val="solid"/>
+                      <a:round/>
+                      <a:headEnd type="none" w="med" len="med"/>
+                      <a:tailEnd type="none" w="med" len="med"/>
+                    </a:lnT>
+                    <a:lnB w="12700" cap="flat" cmpd="sng" algn="ctr">
+                      <a:solidFill>
+                        <a:schemeClr val="tx1"/>
+                      </a:solidFill>
+                      <a:prstDash val="solid"/>
+                      <a:round/>
+                      <a:headEnd type="none" w="med" len="med"/>
+                      <a:tailEnd type="none" w="med" len="med"/>
+                    </a:lnB>
+                    <a:lnTlToBr w="12700" cmpd="sng">
+                      <a:noFill/>
+                      <a:prstDash val="solid"/>
+                    </a:lnTlToBr>
+                    <a:lnBlToTr w="12700" cmpd="sng">
+                      <a:noFill/>
+                      <a:prstDash val="solid"/>
+                    </a:lnBlToTr>
+                    <a:noFill/>
+                  </a:tcPr>
+                </a:tc>
+                <a:extLst>
+                  <a:ext uri="{0D108BD9-81ED-4DB2-BD59-A6C34878D82A}">
+                    <a16:rowId xmlns:a16="http://schemas.microsoft.com/office/drawing/2014/main" val="1830468133"/>
+                  </a:ext>
+                </a:extLst>
+              </a:tr>
+              <a:tr h="1012523">
+                <a:tc>
+                  <a:txBody>
+                    <a:bodyPr/>
+                    <a:lstStyle/>
+                    <a:p>
+                      <a:r>
+                        <a:rPr lang="en-US" b="1"/>
+                        <a:t>PATCH</a:t>
+                      </a:r>
+                    </a:p>
+                  </a:txBody>
+                  <a:tcPr anchor="ctr">
+                    <a:lnL w="12700" cap="flat" cmpd="sng" algn="ctr">
+                      <a:solidFill>
+                        <a:schemeClr val="tx1"/>
+                      </a:solidFill>
+                      <a:prstDash val="solid"/>
+                      <a:round/>
+                      <a:headEnd type="none" w="med" len="med"/>
+                      <a:tailEnd type="none" w="med" len="med"/>
+                    </a:lnL>
+                    <a:lnR w="12700" cap="flat" cmpd="sng" algn="ctr">
+                      <a:solidFill>
+                        <a:schemeClr val="tx1"/>
+                      </a:solidFill>
+                      <a:prstDash val="solid"/>
+                      <a:round/>
+                      <a:headEnd type="none" w="med" len="med"/>
+                      <a:tailEnd type="none" w="med" len="med"/>
+                    </a:lnR>
+                    <a:lnT w="12700" cap="flat" cmpd="sng" algn="ctr">
+                      <a:solidFill>
+                        <a:schemeClr val="tx1"/>
+                      </a:solidFill>
+                      <a:prstDash val="solid"/>
+                      <a:round/>
+                      <a:headEnd type="none" w="med" len="med"/>
+                      <a:tailEnd type="none" w="med" len="med"/>
+                    </a:lnT>
+                    <a:lnB w="12700" cap="flat" cmpd="sng" algn="ctr">
+                      <a:solidFill>
+                        <a:schemeClr val="tx1"/>
+                      </a:solidFill>
+                      <a:prstDash val="solid"/>
+                      <a:round/>
+                      <a:headEnd type="none" w="med" len="med"/>
+                      <a:tailEnd type="none" w="med" len="med"/>
+                    </a:lnB>
+                    <a:lnTlToBr w="12700" cmpd="sng">
+                      <a:noFill/>
+                      <a:prstDash val="solid"/>
+                    </a:lnTlToBr>
+                    <a:lnBlToTr w="12700" cmpd="sng">
+                      <a:noFill/>
+                      <a:prstDash val="solid"/>
+                    </a:lnBlToTr>
+                    <a:noFill/>
+                  </a:tcPr>
+                </a:tc>
+                <a:tc>
+                  <a:txBody>
+                    <a:bodyPr/>
+                    <a:lstStyle/>
+                    <a:p>
+                      <a:r>
+                        <a:rPr lang="en-US" b="1"/>
+                        <a:t>Var olan resursun bir hissəsini dəyişmək</a:t>
+                      </a:r>
+                      <a:endParaRPr lang="en-US"/>
+                    </a:p>
+                  </a:txBody>
+                  <a:tcPr anchor="ctr">
+                    <a:lnL w="12700" cap="flat" cmpd="sng" algn="ctr">
+                      <a:solidFill>
+                        <a:schemeClr val="tx1"/>
+                      </a:solidFill>
+                      <a:prstDash val="solid"/>
+                      <a:round/>
+                      <a:headEnd type="none" w="med" len="med"/>
+                      <a:tailEnd type="none" w="med" len="med"/>
+                    </a:lnL>
+                    <a:lnR w="12700" cap="flat" cmpd="sng" algn="ctr">
+                      <a:solidFill>
+                        <a:schemeClr val="tx1"/>
+                      </a:solidFill>
+                      <a:prstDash val="solid"/>
+                      <a:round/>
+                      <a:headEnd type="none" w="med" len="med"/>
+                      <a:tailEnd type="none" w="med" len="med"/>
+                    </a:lnR>
+                    <a:lnT w="12700" cap="flat" cmpd="sng" algn="ctr">
+                      <a:solidFill>
+                        <a:schemeClr val="tx1"/>
+                      </a:solidFill>
+                      <a:prstDash val="solid"/>
+                      <a:round/>
+                      <a:headEnd type="none" w="med" len="med"/>
+                      <a:tailEnd type="none" w="med" len="med"/>
+                    </a:lnT>
+                    <a:lnB w="12700" cap="flat" cmpd="sng" algn="ctr">
+                      <a:solidFill>
+                        <a:schemeClr val="tx1"/>
+                      </a:solidFill>
+                      <a:prstDash val="solid"/>
+                      <a:round/>
+                      <a:headEnd type="none" w="med" len="med"/>
+                      <a:tailEnd type="none" w="med" len="med"/>
+                    </a:lnB>
+                    <a:lnTlToBr w="12700" cmpd="sng">
+                      <a:noFill/>
+                      <a:prstDash val="solid"/>
+                    </a:lnTlToBr>
+                    <a:lnBlToTr w="12700" cmpd="sng">
+                      <a:noFill/>
+                      <a:prstDash val="solid"/>
+                    </a:lnBlToTr>
+                    <a:noFill/>
+                  </a:tcPr>
+                </a:tc>
+                <a:tc>
+                  <a:txBody>
+                    <a:bodyPr/>
+                    <a:lstStyle/>
+                    <a:p>
+                      <a:r>
+                        <a:rPr lang="en-US"/>
+                        <a:t>Tək sahənin dəyişdirilməsi üçün daha uyğundur (məs: sadəcə name və ya image)</a:t>
+                      </a:r>
+                    </a:p>
+                  </a:txBody>
+                  <a:tcPr anchor="ctr">
+                    <a:lnL w="12700" cap="flat" cmpd="sng" algn="ctr">
+                      <a:solidFill>
+                        <a:schemeClr val="tx1"/>
+                      </a:solidFill>
+                      <a:prstDash val="solid"/>
+                      <a:round/>
+                      <a:headEnd type="none" w="med" len="med"/>
+                      <a:tailEnd type="none" w="med" len="med"/>
+                    </a:lnL>
+                    <a:lnR w="12700" cap="flat" cmpd="sng" algn="ctr">
+                      <a:solidFill>
+                        <a:schemeClr val="tx1"/>
+                      </a:solidFill>
+                      <a:prstDash val="solid"/>
+                      <a:round/>
+                      <a:headEnd type="none" w="med" len="med"/>
+                      <a:tailEnd type="none" w="med" len="med"/>
+                    </a:lnR>
+                    <a:lnT w="12700" cap="flat" cmpd="sng" algn="ctr">
+                      <a:solidFill>
+                        <a:schemeClr val="tx1"/>
+                      </a:solidFill>
+                      <a:prstDash val="solid"/>
+                      <a:round/>
+                      <a:headEnd type="none" w="med" len="med"/>
+                      <a:tailEnd type="none" w="med" len="med"/>
+                    </a:lnT>
+                    <a:lnB w="12700" cap="flat" cmpd="sng" algn="ctr">
+                      <a:solidFill>
+                        <a:schemeClr val="tx1"/>
+                      </a:solidFill>
+                      <a:prstDash val="solid"/>
+                      <a:round/>
+                      <a:headEnd type="none" w="med" len="med"/>
+                      <a:tailEnd type="none" w="med" len="med"/>
+                    </a:lnB>
+                    <a:lnTlToBr w="12700" cmpd="sng">
+                      <a:noFill/>
+                      <a:prstDash val="solid"/>
+                    </a:lnTlToBr>
+                    <a:lnBlToTr w="12700" cmpd="sng">
+                      <a:noFill/>
+                      <a:prstDash val="solid"/>
+                    </a:lnBlToTr>
+                    <a:noFill/>
+                  </a:tcPr>
+                </a:tc>
+                <a:extLst>
+                  <a:ext uri="{0D108BD9-81ED-4DB2-BD59-A6C34878D82A}">
+                    <a16:rowId xmlns:a16="http://schemas.microsoft.com/office/drawing/2014/main" val="1995759643"/>
+                  </a:ext>
+                </a:extLst>
+              </a:tr>
+            </a:tbl>
+          </a:graphicData>
+        </a:graphic>
+      </p:graphicFrame>
     </p:spTree>
     <p:extLst>
       <p:ext uri="{BB962C8B-B14F-4D97-AF65-F5344CB8AC3E}">
@@ -3609,7 +4675,7 @@
         <p:spPr>
           <a:xfrm>
             <a:off x="217714" y="255046"/>
-            <a:ext cx="11756571" cy="355354"/>
+            <a:ext cx="11756571" cy="5456750"/>
           </a:xfrm>
           <a:prstGeom prst="rect">
             <a:avLst/>
@@ -3629,21 +4695,317 @@
               <a:buNone/>
             </a:pPr>
             <a:r>
-              <a:rPr kumimoji="0" lang="en-US" altLang="en-US" sz="1300" b="0" i="0" u="none" strike="noStrike" cap="none" normalizeH="0" baseline="0">
-                <a:ln>
-                  <a:noFill/>
-                </a:ln>
-                <a:solidFill>
-                  <a:schemeClr val="tx1"/>
-                </a:solidFill>
-                <a:effectLst/>
+              <a:rPr lang="en-US" altLang="en-US" sz="1300" b="1">
+                <a:latin typeface="Arial" panose="020B0604020202020204" pitchFamily="34" charset="0"/>
+              </a:rPr>
+              <a:t>Form 1 – Profil məlumatlarını dəyişmək (PUT)</a:t>
+            </a:r>
+            <a:r>
+              <a:rPr lang="az-Latn-AZ" altLang="en-US" sz="1300">
                 <a:latin typeface="Arial" panose="020B0604020202020204" pitchFamily="34" charset="0"/>
               </a:rPr>
               <a:t>.</a:t>
             </a:r>
           </a:p>
-        </p:txBody>
-      </p:sp>
+          <a:p>
+            <a:pPr>
+              <a:lnSpc>
+                <a:spcPct val="150000"/>
+              </a:lnSpc>
+              <a:buNone/>
+            </a:pPr>
+            <a:endParaRPr kumimoji="0" lang="az-Latn-AZ" altLang="en-US" sz="1300" b="0" i="0" u="none" strike="noStrike" cap="none" normalizeH="0" baseline="0">
+              <a:ln>
+                <a:noFill/>
+              </a:ln>
+              <a:solidFill>
+                <a:schemeClr val="tx1"/>
+              </a:solidFill>
+              <a:effectLst/>
+              <a:latin typeface="Arial" panose="020B0604020202020204" pitchFamily="34" charset="0"/>
+            </a:endParaRPr>
+          </a:p>
+          <a:p>
+            <a:pPr>
+              <a:lnSpc>
+                <a:spcPct val="150000"/>
+              </a:lnSpc>
+              <a:buNone/>
+            </a:pPr>
+            <a:endParaRPr lang="az-Latn-AZ" altLang="en-US" sz="1300">
+              <a:latin typeface="Arial" panose="020B0604020202020204" pitchFamily="34" charset="0"/>
+            </a:endParaRPr>
+          </a:p>
+          <a:p>
+            <a:pPr>
+              <a:lnSpc>
+                <a:spcPct val="150000"/>
+              </a:lnSpc>
+              <a:buNone/>
+            </a:pPr>
+            <a:endParaRPr kumimoji="0" lang="az-Latn-AZ" altLang="en-US" sz="1300" b="0" i="0" u="none" strike="noStrike" cap="none" normalizeH="0" baseline="0">
+              <a:ln>
+                <a:noFill/>
+              </a:ln>
+              <a:solidFill>
+                <a:schemeClr val="tx1"/>
+              </a:solidFill>
+              <a:effectLst/>
+              <a:latin typeface="Arial" panose="020B0604020202020204" pitchFamily="34" charset="0"/>
+            </a:endParaRPr>
+          </a:p>
+          <a:p>
+            <a:pPr>
+              <a:lnSpc>
+                <a:spcPct val="150000"/>
+              </a:lnSpc>
+              <a:buNone/>
+            </a:pPr>
+            <a:endParaRPr kumimoji="0" lang="az-Latn-AZ" altLang="en-US" sz="1300" b="0" i="0" u="none" strike="noStrike" cap="none" normalizeH="0" baseline="0">
+              <a:ln>
+                <a:noFill/>
+              </a:ln>
+              <a:solidFill>
+                <a:schemeClr val="tx1"/>
+              </a:solidFill>
+              <a:effectLst/>
+              <a:latin typeface="Arial" panose="020B0604020202020204" pitchFamily="34" charset="0"/>
+            </a:endParaRPr>
+          </a:p>
+          <a:p>
+            <a:pPr>
+              <a:lnSpc>
+                <a:spcPct val="150000"/>
+              </a:lnSpc>
+              <a:buNone/>
+            </a:pPr>
+            <a:r>
+              <a:rPr lang="en-US" altLang="en-US" sz="1300">
+                <a:latin typeface="Arial" panose="020B0604020202020204" pitchFamily="34" charset="0"/>
+              </a:rPr>
+              <a:t>Bu formada istifadəçi name, email, image kimi resursun əsas sahələrini dəyişir – yəni tam profili yeniləyir. Laravel və REST standartlarına görə, bu PUT metoduna uyğundur.</a:t>
+            </a:r>
+            <a:endParaRPr lang="az-Latn-AZ" altLang="en-US" sz="1300">
+              <a:latin typeface="Arial" panose="020B0604020202020204" pitchFamily="34" charset="0"/>
+            </a:endParaRPr>
+          </a:p>
+          <a:p>
+            <a:pPr>
+              <a:lnSpc>
+                <a:spcPct val="150000"/>
+              </a:lnSpc>
+              <a:buNone/>
+            </a:pPr>
+            <a:endParaRPr kumimoji="0" lang="az-Latn-AZ" altLang="en-US" sz="1300" b="0" i="0" u="none" strike="noStrike" cap="none" normalizeH="0" baseline="0">
+              <a:ln>
+                <a:noFill/>
+              </a:ln>
+              <a:solidFill>
+                <a:schemeClr val="tx1"/>
+              </a:solidFill>
+              <a:effectLst/>
+              <a:latin typeface="Arial" panose="020B0604020202020204" pitchFamily="34" charset="0"/>
+            </a:endParaRPr>
+          </a:p>
+          <a:p>
+            <a:pPr>
+              <a:lnSpc>
+                <a:spcPct val="150000"/>
+              </a:lnSpc>
+              <a:buNone/>
+            </a:pPr>
+            <a:endParaRPr lang="az-Latn-AZ" altLang="en-US" sz="1300">
+              <a:latin typeface="Arial" panose="020B0604020202020204" pitchFamily="34" charset="0"/>
+            </a:endParaRPr>
+          </a:p>
+          <a:p>
+            <a:pPr>
+              <a:lnSpc>
+                <a:spcPct val="150000"/>
+              </a:lnSpc>
+              <a:buNone/>
+            </a:pPr>
+            <a:endParaRPr kumimoji="0" lang="az-Latn-AZ" altLang="en-US" sz="1300" b="0" i="0" u="none" strike="noStrike" cap="none" normalizeH="0" baseline="0">
+              <a:ln>
+                <a:noFill/>
+              </a:ln>
+              <a:solidFill>
+                <a:schemeClr val="tx1"/>
+              </a:solidFill>
+              <a:effectLst/>
+              <a:latin typeface="Arial" panose="020B0604020202020204" pitchFamily="34" charset="0"/>
+            </a:endParaRPr>
+          </a:p>
+          <a:p>
+            <a:pPr>
+              <a:lnSpc>
+                <a:spcPct val="150000"/>
+              </a:lnSpc>
+              <a:buNone/>
+            </a:pPr>
+            <a:endParaRPr lang="az-Latn-AZ" altLang="en-US" sz="1300">
+              <a:latin typeface="Arial" panose="020B0604020202020204" pitchFamily="34" charset="0"/>
+            </a:endParaRPr>
+          </a:p>
+          <a:p>
+            <a:pPr>
+              <a:lnSpc>
+                <a:spcPct val="150000"/>
+              </a:lnSpc>
+              <a:buNone/>
+            </a:pPr>
+            <a:r>
+              <a:rPr lang="en-US" altLang="en-US" sz="1300" b="1">
+                <a:latin typeface="Arial" panose="020B0604020202020204" pitchFamily="34" charset="0"/>
+              </a:rPr>
+              <a:t>Form 2 – Şifrə dəyişmək (POST)</a:t>
+            </a:r>
+            <a:r>
+              <a:rPr lang="az-Latn-AZ" altLang="en-US" sz="1300">
+                <a:latin typeface="Arial" panose="020B0604020202020204" pitchFamily="34" charset="0"/>
+              </a:rPr>
+              <a:t>.</a:t>
+            </a:r>
+          </a:p>
+          <a:p>
+            <a:pPr>
+              <a:lnSpc>
+                <a:spcPct val="150000"/>
+              </a:lnSpc>
+              <a:buNone/>
+            </a:pPr>
+            <a:endParaRPr kumimoji="0" lang="az-Latn-AZ" altLang="en-US" sz="1300" b="0" i="0" u="none" strike="noStrike" cap="none" normalizeH="0" baseline="0">
+              <a:ln>
+                <a:noFill/>
+              </a:ln>
+              <a:solidFill>
+                <a:schemeClr val="tx1"/>
+              </a:solidFill>
+              <a:effectLst/>
+              <a:latin typeface="Arial" panose="020B0604020202020204" pitchFamily="34" charset="0"/>
+            </a:endParaRPr>
+          </a:p>
+          <a:p>
+            <a:pPr>
+              <a:lnSpc>
+                <a:spcPct val="150000"/>
+              </a:lnSpc>
+              <a:buNone/>
+            </a:pPr>
+            <a:endParaRPr lang="az-Latn-AZ" altLang="en-US" sz="1300">
+              <a:latin typeface="Arial" panose="020B0604020202020204" pitchFamily="34" charset="0"/>
+            </a:endParaRPr>
+          </a:p>
+          <a:p>
+            <a:pPr>
+              <a:lnSpc>
+                <a:spcPct val="150000"/>
+              </a:lnSpc>
+              <a:buNone/>
+            </a:pPr>
+            <a:endParaRPr kumimoji="0" lang="az-Latn-AZ" altLang="en-US" sz="1300" b="0" i="0" u="none" strike="noStrike" cap="none" normalizeH="0" baseline="0">
+              <a:ln>
+                <a:noFill/>
+              </a:ln>
+              <a:solidFill>
+                <a:schemeClr val="tx1"/>
+              </a:solidFill>
+              <a:effectLst/>
+              <a:latin typeface="Arial" panose="020B0604020202020204" pitchFamily="34" charset="0"/>
+            </a:endParaRPr>
+          </a:p>
+          <a:p>
+            <a:pPr>
+              <a:lnSpc>
+                <a:spcPct val="150000"/>
+              </a:lnSpc>
+              <a:buNone/>
+            </a:pPr>
+            <a:r>
+              <a:rPr lang="en-US" altLang="en-US" sz="1300">
+                <a:latin typeface="Arial" panose="020B0604020202020204" pitchFamily="34" charset="0"/>
+              </a:rPr>
+              <a:t>Bu formada isə current_password, new_password, confirmation kimi sahələr parolu dəyişmək üçün xüsusi bir əməliyyat icra edir. Burada məqsəd user obyektini tam güncəlləmək deyil, əlavə bir aksiya yerinə yetirməkdir. </a:t>
+            </a:r>
+            <a:r>
+              <a:rPr lang="az-Latn-AZ" altLang="en-US" sz="1300">
+                <a:latin typeface="Arial" panose="020B0604020202020204" pitchFamily="34" charset="0"/>
+              </a:rPr>
+              <a:t>Laravel və HTTP konvensiyalarına görə bu, POST metodu ilə daha məntiqli olur, çünki bu bir "custom action" (xüsusi əməliyyatdır).</a:t>
+            </a:r>
+            <a:endParaRPr kumimoji="0" lang="en-US" altLang="en-US" sz="1300" b="0" i="0" u="none" strike="noStrike" cap="none" normalizeH="0" baseline="0">
+              <a:ln>
+                <a:noFill/>
+              </a:ln>
+              <a:solidFill>
+                <a:schemeClr val="tx1"/>
+              </a:solidFill>
+              <a:effectLst/>
+              <a:latin typeface="Arial" panose="020B0604020202020204" pitchFamily="34" charset="0"/>
+            </a:endParaRPr>
+          </a:p>
+        </p:txBody>
+      </p:sp>
+      <p:pic>
+        <p:nvPicPr>
+          <p:cNvPr id="4" name="Picture 3">
+            <a:extLst>
+              <a:ext uri="{FF2B5EF4-FFF2-40B4-BE49-F238E27FC236}">
+                <a16:creationId xmlns:a16="http://schemas.microsoft.com/office/drawing/2014/main" id="{A0390E87-338A-FB8C-A84A-BE989CAE4ADF}"/>
+              </a:ext>
+            </a:extLst>
+          </p:cNvPr>
+          <p:cNvPicPr>
+            <a:picLocks noChangeAspect="1"/>
+          </p:cNvPicPr>
+          <p:nvPr/>
+        </p:nvPicPr>
+        <p:blipFill>
+          <a:blip r:embed="rId2"/>
+          <a:stretch>
+            <a:fillRect/>
+          </a:stretch>
+        </p:blipFill>
+        <p:spPr>
+          <a:xfrm>
+            <a:off x="217714" y="892387"/>
+            <a:ext cx="5020376" cy="638264"/>
+          </a:xfrm>
+          <a:prstGeom prst="rect">
+            <a:avLst/>
+          </a:prstGeom>
+        </p:spPr>
+      </p:pic>
+      <p:pic>
+        <p:nvPicPr>
+          <p:cNvPr id="6" name="Picture 5">
+            <a:extLst>
+              <a:ext uri="{FF2B5EF4-FFF2-40B4-BE49-F238E27FC236}">
+                <a16:creationId xmlns:a16="http://schemas.microsoft.com/office/drawing/2014/main" id="{1DE2B765-8D15-3A17-1BF0-39886A418A15}"/>
+              </a:ext>
+            </a:extLst>
+          </p:cNvPr>
+          <p:cNvPicPr>
+            <a:picLocks noChangeAspect="1"/>
+          </p:cNvPicPr>
+          <p:nvPr/>
+        </p:nvPicPr>
+        <p:blipFill>
+          <a:blip r:embed="rId3"/>
+          <a:stretch>
+            <a:fillRect/>
+          </a:stretch>
+        </p:blipFill>
+        <p:spPr>
+          <a:xfrm>
+            <a:off x="217714" y="4063547"/>
+            <a:ext cx="5725324" cy="447737"/>
+          </a:xfrm>
+          <a:prstGeom prst="rect">
+            <a:avLst/>
+          </a:prstGeom>
+        </p:spPr>
+      </p:pic>
     </p:spTree>
     <p:extLst>
       <p:ext uri="{BB962C8B-B14F-4D97-AF65-F5344CB8AC3E}">
@@ -3695,6 +5057,840 @@
         <p:spPr>
           <a:xfrm>
             <a:off x="217714" y="255046"/>
+            <a:ext cx="11756571" cy="6356997"/>
+          </a:xfrm>
+          <a:prstGeom prst="rect">
+            <a:avLst/>
+          </a:prstGeom>
+          <a:noFill/>
+        </p:spPr>
+        <p:txBody>
+          <a:bodyPr wrap="square">
+            <a:spAutoFit/>
+          </a:bodyPr>
+          <a:lstStyle/>
+          <a:p>
+            <a:pPr>
+              <a:lnSpc>
+                <a:spcPct val="150000"/>
+              </a:lnSpc>
+              <a:buNone/>
+            </a:pPr>
+            <a:r>
+              <a:rPr lang="en-US" altLang="en-US" sz="1300">
+                <a:latin typeface="Arial" panose="020B0604020202020204" pitchFamily="34" charset="0"/>
+              </a:rPr>
+              <a:t>Niyə ikisi də </a:t>
+            </a:r>
+            <a:r>
+              <a:rPr lang="en-US" altLang="en-US" sz="1300" b="1">
+                <a:latin typeface="Arial" panose="020B0604020202020204" pitchFamily="34" charset="0"/>
+              </a:rPr>
+              <a:t>PUT</a:t>
+            </a:r>
+            <a:r>
+              <a:rPr lang="en-US" altLang="en-US" sz="1300">
+                <a:latin typeface="Arial" panose="020B0604020202020204" pitchFamily="34" charset="0"/>
+              </a:rPr>
+              <a:t> olmasın? </a:t>
+            </a:r>
+            <a:endParaRPr lang="az-Latn-AZ" altLang="en-US" sz="1300">
+              <a:latin typeface="Arial" panose="020B0604020202020204" pitchFamily="34" charset="0"/>
+            </a:endParaRPr>
+          </a:p>
+          <a:p>
+            <a:pPr>
+              <a:lnSpc>
+                <a:spcPct val="150000"/>
+              </a:lnSpc>
+              <a:buNone/>
+            </a:pPr>
+            <a:endParaRPr lang="az-Latn-AZ" altLang="en-US" sz="1300">
+              <a:latin typeface="Arial" panose="020B0604020202020204" pitchFamily="34" charset="0"/>
+            </a:endParaRPr>
+          </a:p>
+          <a:p>
+            <a:pPr>
+              <a:lnSpc>
+                <a:spcPct val="150000"/>
+              </a:lnSpc>
+              <a:buNone/>
+            </a:pPr>
+            <a:r>
+              <a:rPr lang="en-US" altLang="en-US" sz="1300">
+                <a:latin typeface="Arial" panose="020B0604020202020204" pitchFamily="34" charset="0"/>
+              </a:rPr>
+              <a:t>Əgər hər ikisini </a:t>
+            </a:r>
+            <a:r>
+              <a:rPr lang="en-US" altLang="en-US" sz="1300" b="1">
+                <a:latin typeface="Arial" panose="020B0604020202020204" pitchFamily="34" charset="0"/>
+              </a:rPr>
+              <a:t>PUT</a:t>
+            </a:r>
+            <a:r>
+              <a:rPr lang="en-US" altLang="en-US" sz="1300">
+                <a:latin typeface="Arial" panose="020B0604020202020204" pitchFamily="34" charset="0"/>
+              </a:rPr>
+              <a:t> etsən, eyni </a:t>
+            </a:r>
+            <a:r>
+              <a:rPr lang="en-US" altLang="en-US" sz="1300" b="1">
+                <a:latin typeface="Arial" panose="020B0604020202020204" pitchFamily="34" charset="0"/>
+              </a:rPr>
+              <a:t>URI</a:t>
+            </a:r>
+            <a:r>
+              <a:rPr lang="en-US" altLang="en-US" sz="1300">
+                <a:latin typeface="Arial" panose="020B0604020202020204" pitchFamily="34" charset="0"/>
+              </a:rPr>
+              <a:t> (</a:t>
+            </a:r>
+            <a:r>
+              <a:rPr lang="az-Latn-AZ" altLang="en-US" sz="1300">
+                <a:latin typeface="Arial" panose="020B0604020202020204" pitchFamily="34" charset="0"/>
+              </a:rPr>
+              <a:t> </a:t>
+            </a:r>
+            <a:r>
+              <a:rPr lang="en-US" altLang="en-US" sz="1300" b="1">
+                <a:latin typeface="Arial" panose="020B0604020202020204" pitchFamily="34" charset="0"/>
+              </a:rPr>
+              <a:t>/user/profile</a:t>
+            </a:r>
+            <a:r>
+              <a:rPr lang="az-Latn-AZ" altLang="en-US" sz="1300" b="1">
+                <a:latin typeface="Arial" panose="020B0604020202020204" pitchFamily="34" charset="0"/>
+              </a:rPr>
+              <a:t> </a:t>
+            </a:r>
+            <a:r>
+              <a:rPr lang="en-US" altLang="en-US" sz="1300">
+                <a:latin typeface="Arial" panose="020B0604020202020204" pitchFamily="34" charset="0"/>
+              </a:rPr>
+              <a:t>) üzərində fərqli metodlara </a:t>
+            </a:r>
+            <a:r>
+              <a:rPr lang="en-US" altLang="en-US" sz="1300" b="1">
+                <a:latin typeface="Arial" panose="020B0604020202020204" pitchFamily="34" charset="0"/>
+              </a:rPr>
+              <a:t>route</a:t>
+            </a:r>
+            <a:r>
+              <a:rPr lang="en-US" altLang="en-US" sz="1300">
+                <a:latin typeface="Arial" panose="020B0604020202020204" pitchFamily="34" charset="0"/>
+              </a:rPr>
+              <a:t> </a:t>
+            </a:r>
+            <a:r>
+              <a:rPr lang="az-Latn-AZ" altLang="en-US" sz="1300">
+                <a:latin typeface="Arial" panose="020B0604020202020204" pitchFamily="34" charset="0"/>
+              </a:rPr>
+              <a:t>vermiş olasıyıq</a:t>
+            </a:r>
+            <a:r>
+              <a:rPr lang="en-US" altLang="en-US" sz="1300">
+                <a:latin typeface="Arial" panose="020B0604020202020204" pitchFamily="34" charset="0"/>
+              </a:rPr>
+              <a:t>:</a:t>
+            </a:r>
+            <a:endParaRPr lang="az-Latn-AZ" altLang="en-US" sz="1300">
+              <a:latin typeface="Arial" panose="020B0604020202020204" pitchFamily="34" charset="0"/>
+            </a:endParaRPr>
+          </a:p>
+          <a:p>
+            <a:pPr>
+              <a:lnSpc>
+                <a:spcPct val="150000"/>
+              </a:lnSpc>
+              <a:buNone/>
+            </a:pPr>
+            <a:endParaRPr kumimoji="0" lang="az-Latn-AZ" altLang="en-US" sz="1300" b="0" i="0" u="none" strike="noStrike" cap="none" normalizeH="0" baseline="0">
+              <a:ln>
+                <a:noFill/>
+              </a:ln>
+              <a:solidFill>
+                <a:schemeClr val="tx1"/>
+              </a:solidFill>
+              <a:effectLst/>
+              <a:latin typeface="Arial" panose="020B0604020202020204" pitchFamily="34" charset="0"/>
+            </a:endParaRPr>
+          </a:p>
+          <a:p>
+            <a:pPr>
+              <a:lnSpc>
+                <a:spcPct val="150000"/>
+              </a:lnSpc>
+              <a:buNone/>
+            </a:pPr>
+            <a:endParaRPr lang="az-Latn-AZ" altLang="en-US" sz="1300">
+              <a:latin typeface="Arial" panose="020B0604020202020204" pitchFamily="34" charset="0"/>
+            </a:endParaRPr>
+          </a:p>
+          <a:p>
+            <a:pPr>
+              <a:lnSpc>
+                <a:spcPct val="150000"/>
+              </a:lnSpc>
+              <a:buNone/>
+            </a:pPr>
+            <a:endParaRPr kumimoji="0" lang="az-Latn-AZ" altLang="en-US" sz="1300" b="0" i="0" u="none" strike="noStrike" cap="none" normalizeH="0" baseline="0">
+              <a:ln>
+                <a:noFill/>
+              </a:ln>
+              <a:solidFill>
+                <a:schemeClr val="tx1"/>
+              </a:solidFill>
+              <a:effectLst/>
+              <a:latin typeface="Arial" panose="020B0604020202020204" pitchFamily="34" charset="0"/>
+            </a:endParaRPr>
+          </a:p>
+          <a:p>
+            <a:pPr>
+              <a:lnSpc>
+                <a:spcPct val="150000"/>
+              </a:lnSpc>
+              <a:buNone/>
+            </a:pPr>
+            <a:r>
+              <a:rPr lang="en-US" altLang="en-US" sz="1300">
+                <a:latin typeface="Arial" panose="020B0604020202020204" pitchFamily="34" charset="0"/>
+              </a:rPr>
+              <a:t>Bu Laravel-də mümkün deyil, çünki eyni HTTP method + URI bir yerdə yalnız bir route tanıya bilər.</a:t>
+            </a:r>
+            <a:endParaRPr lang="az-Latn-AZ" altLang="en-US" sz="1300">
+              <a:latin typeface="Arial" panose="020B0604020202020204" pitchFamily="34" charset="0"/>
+            </a:endParaRPr>
+          </a:p>
+          <a:p>
+            <a:pPr>
+              <a:lnSpc>
+                <a:spcPct val="150000"/>
+              </a:lnSpc>
+              <a:buNone/>
+            </a:pPr>
+            <a:endParaRPr kumimoji="0" lang="az-Latn-AZ" altLang="en-US" sz="1300" b="0" i="0" u="none" strike="noStrike" cap="none" normalizeH="0" baseline="0">
+              <a:ln>
+                <a:noFill/>
+              </a:ln>
+              <a:solidFill>
+                <a:schemeClr val="tx1"/>
+              </a:solidFill>
+              <a:effectLst/>
+              <a:latin typeface="Arial" panose="020B0604020202020204" pitchFamily="34" charset="0"/>
+            </a:endParaRPr>
+          </a:p>
+          <a:p>
+            <a:pPr>
+              <a:lnSpc>
+                <a:spcPct val="150000"/>
+              </a:lnSpc>
+              <a:buNone/>
+            </a:pPr>
+            <a:endParaRPr lang="az-Latn-AZ" altLang="en-US" sz="1300">
+              <a:latin typeface="Arial" panose="020B0604020202020204" pitchFamily="34" charset="0"/>
+            </a:endParaRPr>
+          </a:p>
+          <a:p>
+            <a:pPr>
+              <a:lnSpc>
+                <a:spcPct val="150000"/>
+              </a:lnSpc>
+              <a:buNone/>
+            </a:pPr>
+            <a:endParaRPr kumimoji="0" lang="az-Latn-AZ" altLang="en-US" sz="1300" b="0" i="0" u="none" strike="noStrike" cap="none" normalizeH="0" baseline="0">
+              <a:ln>
+                <a:noFill/>
+              </a:ln>
+              <a:solidFill>
+                <a:schemeClr val="tx1"/>
+              </a:solidFill>
+              <a:effectLst/>
+              <a:latin typeface="Arial" panose="020B0604020202020204" pitchFamily="34" charset="0"/>
+            </a:endParaRPr>
+          </a:p>
+          <a:p>
+            <a:pPr>
+              <a:lnSpc>
+                <a:spcPct val="150000"/>
+              </a:lnSpc>
+              <a:buNone/>
+            </a:pPr>
+            <a:endParaRPr lang="az-Latn-AZ" altLang="en-US" sz="1300">
+              <a:latin typeface="Arial" panose="020B0604020202020204" pitchFamily="34" charset="0"/>
+            </a:endParaRPr>
+          </a:p>
+          <a:p>
+            <a:pPr>
+              <a:lnSpc>
+                <a:spcPct val="150000"/>
+              </a:lnSpc>
+              <a:buNone/>
+            </a:pPr>
+            <a:endParaRPr kumimoji="0" lang="az-Latn-AZ" altLang="en-US" sz="1300" b="0" i="0" u="none" strike="noStrike" cap="none" normalizeH="0" baseline="0">
+              <a:ln>
+                <a:noFill/>
+              </a:ln>
+              <a:solidFill>
+                <a:schemeClr val="tx1"/>
+              </a:solidFill>
+              <a:effectLst/>
+              <a:latin typeface="Arial" panose="020B0604020202020204" pitchFamily="34" charset="0"/>
+            </a:endParaRPr>
+          </a:p>
+          <a:p>
+            <a:pPr>
+              <a:lnSpc>
+                <a:spcPct val="150000"/>
+              </a:lnSpc>
+              <a:buNone/>
+            </a:pPr>
+            <a:endParaRPr lang="az-Latn-AZ" altLang="en-US" sz="1300">
+              <a:latin typeface="Arial" panose="020B0604020202020204" pitchFamily="34" charset="0"/>
+            </a:endParaRPr>
+          </a:p>
+          <a:p>
+            <a:pPr>
+              <a:lnSpc>
+                <a:spcPct val="150000"/>
+              </a:lnSpc>
+              <a:buNone/>
+            </a:pPr>
+            <a:endParaRPr kumimoji="0" lang="az-Latn-AZ" altLang="en-US" sz="1300" b="0" i="0" u="none" strike="noStrike" cap="none" normalizeH="0" baseline="0">
+              <a:ln>
+                <a:noFill/>
+              </a:ln>
+              <a:solidFill>
+                <a:schemeClr val="tx1"/>
+              </a:solidFill>
+              <a:effectLst/>
+              <a:latin typeface="Arial" panose="020B0604020202020204" pitchFamily="34" charset="0"/>
+            </a:endParaRPr>
+          </a:p>
+          <a:p>
+            <a:pPr>
+              <a:lnSpc>
+                <a:spcPct val="150000"/>
+              </a:lnSpc>
+              <a:buNone/>
+            </a:pPr>
+            <a:r>
+              <a:rPr lang="en-US" altLang="en-US" sz="1300">
+                <a:latin typeface="Arial" panose="020B0604020202020204" pitchFamily="34" charset="0"/>
+              </a:rPr>
+              <a:t>Buna görə əgər fərqli əməliyyat edirsənsə (məsələn: profili yenilə, şifrəni dəyiş), bu zaman fərqli </a:t>
+            </a:r>
+            <a:r>
+              <a:rPr lang="en-US" altLang="en-US" sz="1300" b="1">
+                <a:latin typeface="Arial" panose="020B0604020202020204" pitchFamily="34" charset="0"/>
+              </a:rPr>
+              <a:t>HTTP</a:t>
+            </a:r>
+            <a:r>
+              <a:rPr lang="en-US" altLang="en-US" sz="1300">
+                <a:latin typeface="Arial" panose="020B0604020202020204" pitchFamily="34" charset="0"/>
+              </a:rPr>
+              <a:t> metodları və ya fərqli </a:t>
+            </a:r>
+            <a:r>
+              <a:rPr lang="en-US" altLang="en-US" sz="1300" b="1">
+                <a:solidFill>
+                  <a:srgbClr val="FF0000"/>
+                </a:solidFill>
+                <a:latin typeface="Arial" panose="020B0604020202020204" pitchFamily="34" charset="0"/>
+              </a:rPr>
+              <a:t>URL</a:t>
+            </a:r>
+            <a:r>
+              <a:rPr lang="en-US" altLang="en-US" sz="1300">
+                <a:latin typeface="Arial" panose="020B0604020202020204" pitchFamily="34" charset="0"/>
+              </a:rPr>
+              <a:t>-lər istifadə etmək vacibdir.</a:t>
+            </a:r>
+            <a:r>
+              <a:rPr lang="az-Latn-AZ" altLang="en-US" sz="1300">
+                <a:latin typeface="Arial" panose="020B0604020202020204" pitchFamily="34" charset="0"/>
+              </a:rPr>
+              <a:t> </a:t>
+            </a:r>
+            <a:r>
+              <a:rPr lang="az-Latn-AZ" altLang="en-US" sz="1300" b="1">
+                <a:latin typeface="Arial" panose="020B0604020202020204" pitchFamily="34" charset="0"/>
+              </a:rPr>
+              <a:t>Alternativ olaraq şifrə üçün bu da ola bilərdi</a:t>
+            </a:r>
+            <a:r>
+              <a:rPr lang="az-Latn-AZ" altLang="en-US" sz="1300">
+                <a:latin typeface="Arial" panose="020B0604020202020204" pitchFamily="34" charset="0"/>
+              </a:rPr>
+              <a:t>:</a:t>
+            </a:r>
+          </a:p>
+          <a:p>
+            <a:pPr>
+              <a:lnSpc>
+                <a:spcPct val="150000"/>
+              </a:lnSpc>
+              <a:buNone/>
+            </a:pPr>
+            <a:endParaRPr kumimoji="0" lang="az-Latn-AZ" altLang="en-US" sz="1300" b="0" i="0" u="none" strike="noStrike" cap="none" normalizeH="0" baseline="0">
+              <a:ln>
+                <a:noFill/>
+              </a:ln>
+              <a:solidFill>
+                <a:schemeClr val="tx1"/>
+              </a:solidFill>
+              <a:effectLst/>
+              <a:latin typeface="Arial" panose="020B0604020202020204" pitchFamily="34" charset="0"/>
+            </a:endParaRPr>
+          </a:p>
+          <a:p>
+            <a:pPr>
+              <a:lnSpc>
+                <a:spcPct val="150000"/>
+              </a:lnSpc>
+              <a:buNone/>
+            </a:pPr>
+            <a:endParaRPr lang="az-Latn-AZ" altLang="en-US" sz="1300">
+              <a:latin typeface="Arial" panose="020B0604020202020204" pitchFamily="34" charset="0"/>
+            </a:endParaRPr>
+          </a:p>
+          <a:p>
+            <a:pPr>
+              <a:lnSpc>
+                <a:spcPct val="150000"/>
+              </a:lnSpc>
+              <a:buNone/>
+            </a:pPr>
+            <a:endParaRPr kumimoji="0" lang="az-Latn-AZ" altLang="en-US" sz="1300" b="0" i="0" u="none" strike="noStrike" cap="none" normalizeH="0" baseline="0">
+              <a:ln>
+                <a:noFill/>
+              </a:ln>
+              <a:solidFill>
+                <a:schemeClr val="tx1"/>
+              </a:solidFill>
+              <a:effectLst/>
+              <a:latin typeface="Arial" panose="020B0604020202020204" pitchFamily="34" charset="0"/>
+            </a:endParaRPr>
+          </a:p>
+          <a:p>
+            <a:pPr>
+              <a:lnSpc>
+                <a:spcPct val="150000"/>
+              </a:lnSpc>
+              <a:buNone/>
+            </a:pPr>
+            <a:endParaRPr lang="az-Latn-AZ" altLang="en-US" sz="1300">
+              <a:latin typeface="Arial" panose="020B0604020202020204" pitchFamily="34" charset="0"/>
+            </a:endParaRPr>
+          </a:p>
+          <a:p>
+            <a:pPr>
+              <a:lnSpc>
+                <a:spcPct val="150000"/>
+              </a:lnSpc>
+              <a:buNone/>
+            </a:pPr>
+            <a:r>
+              <a:rPr lang="en-US" altLang="en-US" sz="1300">
+                <a:latin typeface="Arial" panose="020B0604020202020204" pitchFamily="34" charset="0"/>
+              </a:rPr>
+              <a:t>Amma POST seçimi də tam doğrudur və daha semantic sayılır.</a:t>
+            </a:r>
+            <a:endParaRPr kumimoji="0" lang="en-US" altLang="en-US" sz="1300" b="0" i="0" u="none" strike="noStrike" cap="none" normalizeH="0" baseline="0">
+              <a:ln>
+                <a:noFill/>
+              </a:ln>
+              <a:solidFill>
+                <a:schemeClr val="tx1"/>
+              </a:solidFill>
+              <a:effectLst/>
+              <a:latin typeface="Arial" panose="020B0604020202020204" pitchFamily="34" charset="0"/>
+            </a:endParaRPr>
+          </a:p>
+        </p:txBody>
+      </p:sp>
+      <p:pic>
+        <p:nvPicPr>
+          <p:cNvPr id="4" name="Picture 3">
+            <a:extLst>
+              <a:ext uri="{FF2B5EF4-FFF2-40B4-BE49-F238E27FC236}">
+                <a16:creationId xmlns:a16="http://schemas.microsoft.com/office/drawing/2014/main" id="{E9503D3B-7AA5-5609-E7BE-49CADC4F325A}"/>
+              </a:ext>
+            </a:extLst>
+          </p:cNvPr>
+          <p:cNvPicPr>
+            <a:picLocks noChangeAspect="1"/>
+          </p:cNvPicPr>
+          <p:nvPr/>
+        </p:nvPicPr>
+        <p:blipFill>
+          <a:blip r:embed="rId2"/>
+          <a:stretch>
+            <a:fillRect/>
+          </a:stretch>
+        </p:blipFill>
+        <p:spPr>
+          <a:xfrm>
+            <a:off x="217714" y="1403148"/>
+            <a:ext cx="7973538" cy="562053"/>
+          </a:xfrm>
+          <a:prstGeom prst="rect">
+            <a:avLst/>
+          </a:prstGeom>
+        </p:spPr>
+      </p:pic>
+      <p:pic>
+        <p:nvPicPr>
+          <p:cNvPr id="6" name="Picture 5">
+            <a:extLst>
+              <a:ext uri="{FF2B5EF4-FFF2-40B4-BE49-F238E27FC236}">
+                <a16:creationId xmlns:a16="http://schemas.microsoft.com/office/drawing/2014/main" id="{3C2D308C-8BFA-29AF-7402-DCD155EF2FA3}"/>
+              </a:ext>
+            </a:extLst>
+          </p:cNvPr>
+          <p:cNvPicPr>
+            <a:picLocks noChangeAspect="1"/>
+          </p:cNvPicPr>
+          <p:nvPr/>
+        </p:nvPicPr>
+        <p:blipFill>
+          <a:blip r:embed="rId3"/>
+          <a:stretch>
+            <a:fillRect/>
+          </a:stretch>
+        </p:blipFill>
+        <p:spPr>
+          <a:xfrm>
+            <a:off x="217714" y="5195620"/>
+            <a:ext cx="8954750" cy="809738"/>
+          </a:xfrm>
+          <a:prstGeom prst="rect">
+            <a:avLst/>
+          </a:prstGeom>
+        </p:spPr>
+      </p:pic>
+    </p:spTree>
+    <p:extLst>
+      <p:ext uri="{BB962C8B-B14F-4D97-AF65-F5344CB8AC3E}">
+        <p14:creationId xmlns:p14="http://schemas.microsoft.com/office/powerpoint/2010/main" val="3095838342"/>
+      </p:ext>
+    </p:extLst>
+  </p:cSld>
+  <p:clrMapOvr>
+    <a:masterClrMapping/>
+  </p:clrMapOvr>
+</p:sld>
+</file>
+
+<file path=ppt/slides/slide6.xml><?xml version="1.0" encoding="utf-8"?>
+<p:sld xmlns:a="http://schemas.openxmlformats.org/drawingml/2006/main" xmlns:r="http://schemas.openxmlformats.org/officeDocument/2006/relationships" xmlns:p="http://schemas.openxmlformats.org/presentationml/2006/main">
+  <p:cSld>
+    <p:spTree>
+      <p:nvGrpSpPr>
+        <p:cNvPr id="1" name="">
+          <a:extLst>
+            <a:ext uri="{FF2B5EF4-FFF2-40B4-BE49-F238E27FC236}">
+              <a16:creationId xmlns:a16="http://schemas.microsoft.com/office/drawing/2014/main" id="{66321183-933A-A364-5ACB-2EBE022DCA8D}"/>
+            </a:ext>
+          </a:extLst>
+        </p:cNvPr>
+        <p:cNvGrpSpPr/>
+        <p:nvPr/>
+      </p:nvGrpSpPr>
+      <p:grpSpPr>
+        <a:xfrm>
+          <a:off x="0" y="0"/>
+          <a:ext cx="0" cy="0"/>
+          <a:chOff x="0" y="0"/>
+          <a:chExt cx="0" cy="0"/>
+        </a:xfrm>
+      </p:grpSpPr>
+      <p:sp>
+        <p:nvSpPr>
+          <p:cNvPr id="3" name="TextBox 2">
+            <a:extLst>
+              <a:ext uri="{FF2B5EF4-FFF2-40B4-BE49-F238E27FC236}">
+                <a16:creationId xmlns:a16="http://schemas.microsoft.com/office/drawing/2014/main" id="{1DDED250-657F-651B-CF6B-83C770553AAC}"/>
+              </a:ext>
+            </a:extLst>
+          </p:cNvPr>
+          <p:cNvSpPr txBox="1"/>
+          <p:nvPr/>
+        </p:nvSpPr>
+        <p:spPr>
+          <a:xfrm>
+            <a:off x="217714" y="255046"/>
+            <a:ext cx="11756571" cy="355354"/>
+          </a:xfrm>
+          <a:prstGeom prst="rect">
+            <a:avLst/>
+          </a:prstGeom>
+          <a:noFill/>
+        </p:spPr>
+        <p:txBody>
+          <a:bodyPr wrap="square">
+            <a:spAutoFit/>
+          </a:bodyPr>
+          <a:lstStyle/>
+          <a:p>
+            <a:pPr>
+              <a:lnSpc>
+                <a:spcPct val="150000"/>
+              </a:lnSpc>
+              <a:buNone/>
+            </a:pPr>
+            <a:r>
+              <a:rPr lang="en-US" altLang="en-US" sz="1300">
+                <a:latin typeface="Arial" panose="020B0604020202020204" pitchFamily="34" charset="0"/>
+              </a:rPr>
+              <a:t>Controller -imizi </a:t>
+            </a:r>
+            <a:r>
+              <a:rPr lang="az-Latn-AZ" altLang="en-US" sz="1300">
+                <a:latin typeface="Arial" panose="020B0604020202020204" pitchFamily="34" charset="0"/>
+              </a:rPr>
+              <a:t>yazırıq.</a:t>
+            </a:r>
+            <a:endParaRPr kumimoji="0" lang="en-US" altLang="en-US" sz="1300" b="0" i="0" u="none" strike="noStrike" cap="none" normalizeH="0" baseline="0">
+              <a:ln>
+                <a:noFill/>
+              </a:ln>
+              <a:solidFill>
+                <a:schemeClr val="tx1"/>
+              </a:solidFill>
+              <a:effectLst/>
+              <a:latin typeface="Arial" panose="020B0604020202020204" pitchFamily="34" charset="0"/>
+            </a:endParaRPr>
+          </a:p>
+        </p:txBody>
+      </p:sp>
+      <p:pic>
+        <p:nvPicPr>
+          <p:cNvPr id="4" name="Picture 3">
+            <a:extLst>
+              <a:ext uri="{FF2B5EF4-FFF2-40B4-BE49-F238E27FC236}">
+                <a16:creationId xmlns:a16="http://schemas.microsoft.com/office/drawing/2014/main" id="{65FDFBFD-C0C0-CDDA-4CE1-30757F749E21}"/>
+              </a:ext>
+            </a:extLst>
+          </p:cNvPr>
+          <p:cNvPicPr>
+            <a:picLocks noChangeAspect="1"/>
+          </p:cNvPicPr>
+          <p:nvPr/>
+        </p:nvPicPr>
+        <p:blipFill>
+          <a:blip r:embed="rId2"/>
+          <a:stretch>
+            <a:fillRect/>
+          </a:stretch>
+        </p:blipFill>
+        <p:spPr>
+          <a:xfrm>
+            <a:off x="6874680" y="0"/>
+            <a:ext cx="5317320" cy="6858000"/>
+          </a:xfrm>
+          <a:prstGeom prst="rect">
+            <a:avLst/>
+          </a:prstGeom>
+        </p:spPr>
+      </p:pic>
+    </p:spTree>
+    <p:extLst>
+      <p:ext uri="{BB962C8B-B14F-4D97-AF65-F5344CB8AC3E}">
+        <p14:creationId xmlns:p14="http://schemas.microsoft.com/office/powerpoint/2010/main" val="161863155"/>
+      </p:ext>
+    </p:extLst>
+  </p:cSld>
+  <p:clrMapOvr>
+    <a:masterClrMapping/>
+  </p:clrMapOvr>
+</p:sld>
+</file>
+
+<file path=ppt/slides/slide7.xml><?xml version="1.0" encoding="utf-8"?>
+<p:sld xmlns:a="http://schemas.openxmlformats.org/drawingml/2006/main" xmlns:r="http://schemas.openxmlformats.org/officeDocument/2006/relationships" xmlns:p="http://schemas.openxmlformats.org/presentationml/2006/main">
+  <p:cSld>
+    <p:spTree>
+      <p:nvGrpSpPr>
+        <p:cNvPr id="1" name="">
+          <a:extLst>
+            <a:ext uri="{FF2B5EF4-FFF2-40B4-BE49-F238E27FC236}">
+              <a16:creationId xmlns:a16="http://schemas.microsoft.com/office/drawing/2014/main" id="{07C2A837-8656-3126-16ED-ACC3FCA88DEE}"/>
+            </a:ext>
+          </a:extLst>
+        </p:cNvPr>
+        <p:cNvGrpSpPr/>
+        <p:nvPr/>
+      </p:nvGrpSpPr>
+      <p:grpSpPr>
+        <a:xfrm>
+          <a:off x="0" y="0"/>
+          <a:ext cx="0" cy="0"/>
+          <a:chOff x="0" y="0"/>
+          <a:chExt cx="0" cy="0"/>
+        </a:xfrm>
+      </p:grpSpPr>
+      <p:sp>
+        <p:nvSpPr>
+          <p:cNvPr id="3" name="TextBox 2">
+            <a:extLst>
+              <a:ext uri="{FF2B5EF4-FFF2-40B4-BE49-F238E27FC236}">
+                <a16:creationId xmlns:a16="http://schemas.microsoft.com/office/drawing/2014/main" id="{4E2FF10A-23FE-4297-574F-1B9179DE36BB}"/>
+              </a:ext>
+            </a:extLst>
+          </p:cNvPr>
+          <p:cNvSpPr txBox="1"/>
+          <p:nvPr/>
+        </p:nvSpPr>
+        <p:spPr>
+          <a:xfrm>
+            <a:off x="217714" y="255046"/>
+            <a:ext cx="11756571" cy="655436"/>
+          </a:xfrm>
+          <a:prstGeom prst="rect">
+            <a:avLst/>
+          </a:prstGeom>
+          <a:noFill/>
+        </p:spPr>
+        <p:txBody>
+          <a:bodyPr wrap="square">
+            <a:spAutoFit/>
+          </a:bodyPr>
+          <a:lstStyle/>
+          <a:p>
+            <a:pPr>
+              <a:lnSpc>
+                <a:spcPct val="150000"/>
+              </a:lnSpc>
+              <a:buNone/>
+            </a:pPr>
+            <a:r>
+              <a:rPr lang="az-Latn-AZ" altLang="en-US" sz="1300">
+                <a:latin typeface="Arial" panose="020B0604020202020204" pitchFamily="34" charset="0"/>
+              </a:rPr>
+              <a:t>Tətbiqi test edirik.</a:t>
+            </a:r>
+          </a:p>
+          <a:p>
+            <a:pPr>
+              <a:lnSpc>
+                <a:spcPct val="150000"/>
+              </a:lnSpc>
+              <a:buNone/>
+            </a:pPr>
+            <a:r>
+              <a:rPr lang="az-Latn-AZ" altLang="en-US" sz="1300">
+                <a:latin typeface="Arial" panose="020B0604020202020204" pitchFamily="34" charset="0"/>
+              </a:rPr>
+              <a:t>Şifrə </a:t>
+            </a:r>
+            <a:r>
+              <a:rPr lang="az-Latn-AZ" altLang="en-US" sz="1300" b="1">
+                <a:latin typeface="Arial" panose="020B0604020202020204" pitchFamily="34" charset="0"/>
+              </a:rPr>
+              <a:t>UPDATE</a:t>
+            </a:r>
+            <a:r>
+              <a:rPr lang="az-Latn-AZ" altLang="en-US" sz="1300">
+                <a:latin typeface="Arial" panose="020B0604020202020204" pitchFamily="34" charset="0"/>
+              </a:rPr>
+              <a:t> edildi. Köhnə şifrə 11111111 idi və 22222222 ilə əvəz edildi.</a:t>
+            </a:r>
+            <a:endParaRPr kumimoji="0" lang="en-US" altLang="en-US" sz="1300" b="0" i="0" u="none" strike="noStrike" cap="none" normalizeH="0" baseline="0">
+              <a:ln>
+                <a:noFill/>
+              </a:ln>
+              <a:solidFill>
+                <a:schemeClr val="tx1"/>
+              </a:solidFill>
+              <a:effectLst/>
+              <a:latin typeface="Arial" panose="020B0604020202020204" pitchFamily="34" charset="0"/>
+            </a:endParaRPr>
+          </a:p>
+        </p:txBody>
+      </p:sp>
+      <p:pic>
+        <p:nvPicPr>
+          <p:cNvPr id="4" name="Picture 3">
+            <a:extLst>
+              <a:ext uri="{FF2B5EF4-FFF2-40B4-BE49-F238E27FC236}">
+                <a16:creationId xmlns:a16="http://schemas.microsoft.com/office/drawing/2014/main" id="{C8182DA4-260A-C09D-696D-4A044F300869}"/>
+              </a:ext>
+            </a:extLst>
+          </p:cNvPr>
+          <p:cNvPicPr>
+            <a:picLocks noChangeAspect="1"/>
+          </p:cNvPicPr>
+          <p:nvPr/>
+        </p:nvPicPr>
+        <p:blipFill>
+          <a:blip r:embed="rId2"/>
+          <a:stretch>
+            <a:fillRect/>
+          </a:stretch>
+        </p:blipFill>
+        <p:spPr>
+          <a:xfrm>
+            <a:off x="-1" y="1203555"/>
+            <a:ext cx="12192000" cy="5654445"/>
+          </a:xfrm>
+          <a:prstGeom prst="rect">
+            <a:avLst/>
+          </a:prstGeom>
+        </p:spPr>
+      </p:pic>
+    </p:spTree>
+    <p:extLst>
+      <p:ext uri="{BB962C8B-B14F-4D97-AF65-F5344CB8AC3E}">
+        <p14:creationId xmlns:p14="http://schemas.microsoft.com/office/powerpoint/2010/main" val="3466138058"/>
+      </p:ext>
+    </p:extLst>
+  </p:cSld>
+  <p:clrMapOvr>
+    <a:masterClrMapping/>
+  </p:clrMapOvr>
+</p:sld>
+</file>
+
+<file path=ppt/slides/slide8.xml><?xml version="1.0" encoding="utf-8"?>
+<p:sld xmlns:a="http://schemas.openxmlformats.org/drawingml/2006/main" xmlns:r="http://schemas.openxmlformats.org/officeDocument/2006/relationships" xmlns:p="http://schemas.openxmlformats.org/presentationml/2006/main">
+  <p:cSld>
+    <p:spTree>
+      <p:nvGrpSpPr>
+        <p:cNvPr id="1" name="">
+          <a:extLst>
+            <a:ext uri="{FF2B5EF4-FFF2-40B4-BE49-F238E27FC236}">
+              <a16:creationId xmlns:a16="http://schemas.microsoft.com/office/drawing/2014/main" id="{5B5E9599-BCF3-B711-76EA-093B215ABA8A}"/>
+            </a:ext>
+          </a:extLst>
+        </p:cNvPr>
+        <p:cNvGrpSpPr/>
+        <p:nvPr/>
+      </p:nvGrpSpPr>
+      <p:grpSpPr>
+        <a:xfrm>
+          <a:off x="0" y="0"/>
+          <a:ext cx="0" cy="0"/>
+          <a:chOff x="0" y="0"/>
+          <a:chExt cx="0" cy="0"/>
+        </a:xfrm>
+      </p:grpSpPr>
+      <p:sp>
+        <p:nvSpPr>
+          <p:cNvPr id="3" name="TextBox 2">
+            <a:extLst>
+              <a:ext uri="{FF2B5EF4-FFF2-40B4-BE49-F238E27FC236}">
+                <a16:creationId xmlns:a16="http://schemas.microsoft.com/office/drawing/2014/main" id="{0AE9AFE9-8DCA-48E2-BA74-6DD37707A1B6}"/>
+              </a:ext>
+            </a:extLst>
+          </p:cNvPr>
+          <p:cNvSpPr txBox="1"/>
+          <p:nvPr/>
+        </p:nvSpPr>
+        <p:spPr>
+          <a:xfrm>
+            <a:off x="217714" y="255046"/>
             <a:ext cx="11756571" cy="355354"/>
           </a:xfrm>
           <a:prstGeom prst="rect">
@@ -3733,7 +5929,93 @@
     </p:spTree>
     <p:extLst>
       <p:ext uri="{BB962C8B-B14F-4D97-AF65-F5344CB8AC3E}">
-        <p14:creationId xmlns:p14="http://schemas.microsoft.com/office/powerpoint/2010/main" val="3095838342"/>
+        <p14:creationId xmlns:p14="http://schemas.microsoft.com/office/powerpoint/2010/main" val="1516606281"/>
+      </p:ext>
+    </p:extLst>
+  </p:cSld>
+  <p:clrMapOvr>
+    <a:masterClrMapping/>
+  </p:clrMapOvr>
+</p:sld>
+</file>
+
+<file path=ppt/slides/slide9.xml><?xml version="1.0" encoding="utf-8"?>
+<p:sld xmlns:a="http://schemas.openxmlformats.org/drawingml/2006/main" xmlns:r="http://schemas.openxmlformats.org/officeDocument/2006/relationships" xmlns:p="http://schemas.openxmlformats.org/presentationml/2006/main">
+  <p:cSld>
+    <p:spTree>
+      <p:nvGrpSpPr>
+        <p:cNvPr id="1" name="">
+          <a:extLst>
+            <a:ext uri="{FF2B5EF4-FFF2-40B4-BE49-F238E27FC236}">
+              <a16:creationId xmlns:a16="http://schemas.microsoft.com/office/drawing/2014/main" id="{1E524E5F-D4C2-E812-9B9E-7AEA066A6948}"/>
+            </a:ext>
+          </a:extLst>
+        </p:cNvPr>
+        <p:cNvGrpSpPr/>
+        <p:nvPr/>
+      </p:nvGrpSpPr>
+      <p:grpSpPr>
+        <a:xfrm>
+          <a:off x="0" y="0"/>
+          <a:ext cx="0" cy="0"/>
+          <a:chOff x="0" y="0"/>
+          <a:chExt cx="0" cy="0"/>
+        </a:xfrm>
+      </p:grpSpPr>
+      <p:sp>
+        <p:nvSpPr>
+          <p:cNvPr id="3" name="TextBox 2">
+            <a:extLst>
+              <a:ext uri="{FF2B5EF4-FFF2-40B4-BE49-F238E27FC236}">
+                <a16:creationId xmlns:a16="http://schemas.microsoft.com/office/drawing/2014/main" id="{DB35CB87-5ED2-0590-ED7B-F6CB18513667}"/>
+              </a:ext>
+            </a:extLst>
+          </p:cNvPr>
+          <p:cNvSpPr txBox="1"/>
+          <p:nvPr/>
+        </p:nvSpPr>
+        <p:spPr>
+          <a:xfrm>
+            <a:off x="217714" y="255046"/>
+            <a:ext cx="11756571" cy="355354"/>
+          </a:xfrm>
+          <a:prstGeom prst="rect">
+            <a:avLst/>
+          </a:prstGeom>
+          <a:noFill/>
+        </p:spPr>
+        <p:txBody>
+          <a:bodyPr wrap="square">
+            <a:spAutoFit/>
+          </a:bodyPr>
+          <a:lstStyle/>
+          <a:p>
+            <a:pPr>
+              <a:lnSpc>
+                <a:spcPct val="150000"/>
+              </a:lnSpc>
+              <a:buNone/>
+            </a:pPr>
+            <a:r>
+              <a:rPr kumimoji="0" lang="en-US" altLang="en-US" sz="1300" b="0" i="0" u="none" strike="noStrike" cap="none" normalizeH="0" baseline="0">
+                <a:ln>
+                  <a:noFill/>
+                </a:ln>
+                <a:solidFill>
+                  <a:schemeClr val="tx1"/>
+                </a:solidFill>
+                <a:effectLst/>
+                <a:latin typeface="Arial" panose="020B0604020202020204" pitchFamily="34" charset="0"/>
+              </a:rPr>
+              <a:t>.</a:t>
+            </a:r>
+          </a:p>
+        </p:txBody>
+      </p:sp>
+    </p:spTree>
+    <p:extLst>
+      <p:ext uri="{BB962C8B-B14F-4D97-AF65-F5344CB8AC3E}">
+        <p14:creationId xmlns:p14="http://schemas.microsoft.com/office/powerpoint/2010/main" val="2133878493"/>
       </p:ext>
     </p:extLst>
   </p:cSld>

</xml_diff>